<commit_message>
Clean dead code, enforce altitude constraint, fold adjustments into report & deck
- Remove unused schema models (WeatherCell/WeatherGrid/UAVState/PlanRequest/ScenarioState) and config constants
- Enforce UAV altitude band (100-3000 m) in the API; altitude scales radar exposure
- README/ARCHITECTURE: Astana theatre + box-relative design + altitude notes
- Deck: theatre label (Astana region, KZ) + constraints caption; add scripts/build_deck.js
- 21 tests pass, backend compiles clean, no TODOs/debug prints

Co-Authored-By: Claude Opus 4.8 <noreply@anthropic.com>
</commit_message>
<xml_diff>
--- a/docs/UAV_DSS_Deck.pptx
+++ b/docs/UAV_DSS_Deck.pptx
@@ -6462,7 +6462,46 @@
       </p:sp>
       <p:sp>
         <p:nvSpPr>
-          <p:cNvPr id="5" name="Shape 3"/>
+          <p:cNvPr id="5" name="Text 3"/>
+          <p:cNvSpPr txBox="1"/>
+          <p:nvPr/>
+        </p:nvSpPr>
+        <p:spPr>
+          <a:xfrm>
+            <a:off x="1005840" y="1956816"/>
+            <a:ext cx="5943600" cy="274320"/>
+          </a:xfrm>
+          <a:prstGeom prst="rect">
+            <a:avLst/>
+          </a:prstGeom>
+          <a:noFill/>
+          <a:ln/>
+        </p:spPr>
+        <p:txBody>
+          <a:bodyPr wrap="square" lIns="0" tIns="0" rIns="0" bIns="0" rtlCol="0" anchor="ctr"/>
+          <a:lstStyle/>
+          <a:p>
+            <a:pPr indent="0" marL="0">
+              <a:buNone/>
+            </a:pPr>
+            <a:r>
+              <a:rPr lang="en-US" sz="1000" b="1" spc="200" kern="0" dirty="0">
+                <a:solidFill>
+                  <a:srgbClr val="90A4C4"/>
+                </a:solidFill>
+                <a:latin typeface="Arial" pitchFamily="34" charset="0"/>
+                <a:ea typeface="Arial" pitchFamily="34" charset="-122"/>
+                <a:cs typeface="Arial" pitchFamily="34" charset="-120"/>
+              </a:rPr>
+              <a:t>THEATRE · ASTANA REGION, KAZAKHSTAN</a:t>
+            </a:r>
+            <a:endParaRPr lang="en-US" sz="1000" dirty="0"/>
+          </a:p>
+        </p:txBody>
+      </p:sp>
+      <p:sp>
+        <p:nvSpPr>
+          <p:cNvPr id="6" name="Shape 4"/>
           <p:cNvSpPr/>
           <p:nvPr/>
         </p:nvSpPr>
@@ -6489,7 +6528,7 @@
       </p:sp>
       <p:sp>
         <p:nvSpPr>
-          <p:cNvPr id="6" name="Shape 4"/>
+          <p:cNvPr id="7" name="Shape 5"/>
           <p:cNvSpPr/>
           <p:nvPr/>
         </p:nvSpPr>
@@ -6516,7 +6555,7 @@
       </p:sp>
       <p:sp>
         <p:nvSpPr>
-          <p:cNvPr id="7" name="Text 5"/>
+          <p:cNvPr id="8" name="Text 6"/>
           <p:cNvSpPr txBox="1"/>
           <p:nvPr/>
         </p:nvSpPr>
@@ -6555,7 +6594,7 @@
       </p:sp>
       <p:sp>
         <p:nvSpPr>
-          <p:cNvPr id="8" name="Shape 6"/>
+          <p:cNvPr id="9" name="Shape 7"/>
           <p:cNvSpPr/>
           <p:nvPr/>
         </p:nvSpPr>
@@ -6580,7 +6619,7 @@
       </p:sp>
       <p:sp>
         <p:nvSpPr>
-          <p:cNvPr id="9" name="Shape 7"/>
+          <p:cNvPr id="10" name="Shape 8"/>
           <p:cNvSpPr/>
           <p:nvPr/>
         </p:nvSpPr>
@@ -6605,7 +6644,7 @@
       </p:sp>
       <p:sp>
         <p:nvSpPr>
-          <p:cNvPr id="10" name="Shape 8"/>
+          <p:cNvPr id="11" name="Shape 9"/>
           <p:cNvSpPr/>
           <p:nvPr/>
         </p:nvSpPr>
@@ -6630,7 +6669,7 @@
       </p:sp>
       <p:sp>
         <p:nvSpPr>
-          <p:cNvPr id="11" name="Shape 9"/>
+          <p:cNvPr id="12" name="Shape 10"/>
           <p:cNvSpPr/>
           <p:nvPr/>
         </p:nvSpPr>
@@ -6655,7 +6694,7 @@
       </p:sp>
       <p:sp>
         <p:nvSpPr>
-          <p:cNvPr id="12" name="Shape 10"/>
+          <p:cNvPr id="13" name="Shape 11"/>
           <p:cNvSpPr/>
           <p:nvPr/>
         </p:nvSpPr>
@@ -6675,7 +6714,7 @@
       </p:sp>
       <p:sp>
         <p:nvSpPr>
-          <p:cNvPr id="13" name="Text 11"/>
+          <p:cNvPr id="14" name="Text 12"/>
           <p:cNvSpPr txBox="1"/>
           <p:nvPr/>
         </p:nvSpPr>
@@ -6714,7 +6753,7 @@
       </p:sp>
       <p:sp>
         <p:nvSpPr>
-          <p:cNvPr id="14" name="Shape 12"/>
+          <p:cNvPr id="15" name="Shape 13"/>
           <p:cNvSpPr/>
           <p:nvPr/>
         </p:nvSpPr>
@@ -6734,7 +6773,7 @@
       </p:sp>
       <p:sp>
         <p:nvSpPr>
-          <p:cNvPr id="15" name="Text 13"/>
+          <p:cNvPr id="16" name="Text 14"/>
           <p:cNvSpPr txBox="1"/>
           <p:nvPr/>
         </p:nvSpPr>
@@ -6773,7 +6812,7 @@
       </p:sp>
       <p:sp>
         <p:nvSpPr>
-          <p:cNvPr id="16" name="Text 14"/>
+          <p:cNvPr id="17" name="Text 15"/>
           <p:cNvSpPr txBox="1"/>
           <p:nvPr/>
         </p:nvSpPr>
@@ -6812,7 +6851,7 @@
       </p:sp>
       <p:sp>
         <p:nvSpPr>
-          <p:cNvPr id="17" name="Shape 15"/>
+          <p:cNvPr id="18" name="Shape 16"/>
           <p:cNvSpPr/>
           <p:nvPr/>
         </p:nvSpPr>
@@ -6835,7 +6874,7 @@
       </p:sp>
       <p:sp>
         <p:nvSpPr>
-          <p:cNvPr id="18" name="Text 16"/>
+          <p:cNvPr id="19" name="Text 17"/>
           <p:cNvSpPr txBox="1"/>
           <p:nvPr/>
         </p:nvSpPr>
@@ -6874,7 +6913,7 @@
       </p:sp>
       <p:sp>
         <p:nvSpPr>
-          <p:cNvPr id="19" name="Text 17"/>
+          <p:cNvPr id="20" name="Text 18"/>
           <p:cNvSpPr txBox="1"/>
           <p:nvPr/>
         </p:nvSpPr>
@@ -6913,7 +6952,7 @@
       </p:sp>
       <p:sp>
         <p:nvSpPr>
-          <p:cNvPr id="20" name="Shape 18"/>
+          <p:cNvPr id="21" name="Shape 19"/>
           <p:cNvSpPr/>
           <p:nvPr/>
         </p:nvSpPr>
@@ -6936,7 +6975,7 @@
       </p:sp>
       <p:sp>
         <p:nvSpPr>
-          <p:cNvPr id="21" name="Text 19"/>
+          <p:cNvPr id="22" name="Text 20"/>
           <p:cNvSpPr txBox="1"/>
           <p:nvPr/>
         </p:nvSpPr>
@@ -6975,7 +7014,7 @@
       </p:sp>
       <p:sp>
         <p:nvSpPr>
-          <p:cNvPr id="22" name="Text 20"/>
+          <p:cNvPr id="23" name="Text 21"/>
           <p:cNvSpPr txBox="1"/>
           <p:nvPr/>
         </p:nvSpPr>
@@ -7014,7 +7053,7 @@
       </p:sp>
       <p:sp>
         <p:nvSpPr>
-          <p:cNvPr id="23" name="Shape 21"/>
+          <p:cNvPr id="24" name="Shape 22"/>
           <p:cNvSpPr/>
           <p:nvPr/>
         </p:nvSpPr>
@@ -7037,7 +7076,7 @@
       </p:sp>
       <p:sp>
         <p:nvSpPr>
-          <p:cNvPr id="24" name="Text 22"/>
+          <p:cNvPr id="25" name="Text 23"/>
           <p:cNvSpPr txBox="1"/>
           <p:nvPr/>
         </p:nvSpPr>
@@ -7076,7 +7115,7 @@
       </p:sp>
       <p:sp>
         <p:nvSpPr>
-          <p:cNvPr id="25" name="Text 23"/>
+          <p:cNvPr id="26" name="Text 24"/>
           <p:cNvSpPr txBox="1"/>
           <p:nvPr/>
         </p:nvSpPr>
@@ -7115,7 +7154,7 @@
       </p:sp>
       <p:sp>
         <p:nvSpPr>
-          <p:cNvPr id="26" name="Shape 24"/>
+          <p:cNvPr id="27" name="Shape 25"/>
           <p:cNvSpPr/>
           <p:nvPr/>
         </p:nvSpPr>
@@ -7149,7 +7188,7 @@
       </p:sp>
       <p:sp>
         <p:nvSpPr>
-          <p:cNvPr id="27" name="Text 25"/>
+          <p:cNvPr id="28" name="Text 26"/>
           <p:cNvSpPr txBox="1"/>
           <p:nvPr/>
         </p:nvSpPr>
@@ -7188,7 +7227,7 @@
       </p:sp>
       <p:sp>
         <p:nvSpPr>
-          <p:cNvPr id="28" name="Text 26"/>
+          <p:cNvPr id="29" name="Text 27"/>
           <p:cNvSpPr txBox="1"/>
           <p:nvPr/>
         </p:nvSpPr>
@@ -7227,7 +7266,7 @@
       </p:sp>
       <p:sp>
         <p:nvSpPr>
-          <p:cNvPr id="29" name="Text 27"/>
+          <p:cNvPr id="30" name="Text 28"/>
           <p:cNvSpPr txBox="1"/>
           <p:nvPr/>
         </p:nvSpPr>
@@ -7266,7 +7305,7 @@
       </p:sp>
       <p:sp>
         <p:nvSpPr>
-          <p:cNvPr id="30" name="Text 28"/>
+          <p:cNvPr id="31" name="Text 29"/>
           <p:cNvSpPr txBox="1"/>
           <p:nvPr/>
         </p:nvSpPr>
@@ -7305,7 +7344,7 @@
       </p:sp>
       <p:sp>
         <p:nvSpPr>
-          <p:cNvPr id="31" name="Text 29"/>
+          <p:cNvPr id="32" name="Text 30"/>
           <p:cNvSpPr txBox="1"/>
           <p:nvPr/>
         </p:nvSpPr>
@@ -7344,7 +7383,7 @@
       </p:sp>
       <p:sp>
         <p:nvSpPr>
-          <p:cNvPr id="32" name="Text 30"/>
+          <p:cNvPr id="33" name="Text 31"/>
           <p:cNvSpPr txBox="1"/>
           <p:nvPr/>
         </p:nvSpPr>
@@ -7383,7 +7422,7 @@
       </p:sp>
       <p:sp>
         <p:nvSpPr>
-          <p:cNvPr id="33" name="Text 31"/>
+          <p:cNvPr id="34" name="Text 32"/>
           <p:cNvSpPr txBox="1"/>
           <p:nvPr/>
         </p:nvSpPr>
@@ -7417,6 +7456,45 @@
               <a:t>color-coded</a:t>
             </a:r>
             <a:endParaRPr lang="en-US" sz="1300" dirty="0"/>
+          </a:p>
+        </p:txBody>
+      </p:sp>
+      <p:sp>
+        <p:nvSpPr>
+          <p:cNvPr id="35" name="Text 33"/>
+          <p:cNvSpPr txBox="1"/>
+          <p:nvPr/>
+        </p:nvSpPr>
+        <p:spPr>
+          <a:xfrm>
+            <a:off x="822960" y="6400800"/>
+            <a:ext cx="10515600" cy="320040"/>
+          </a:xfrm>
+          <a:prstGeom prst="rect">
+            <a:avLst/>
+          </a:prstGeom>
+          <a:noFill/>
+          <a:ln/>
+        </p:spPr>
+        <p:txBody>
+          <a:bodyPr wrap="square" lIns="0" tIns="0" rIns="0" bIns="0" rtlCol="0" anchor="ctr"/>
+          <a:lstStyle/>
+          <a:p>
+            <a:pPr indent="0" marL="0">
+              <a:buNone/>
+            </a:pPr>
+            <a:r>
+              <a:rPr lang="en-US" sz="1100" i="1" dirty="0">
+                <a:solidFill>
+                  <a:srgbClr val="90A4C4"/>
+                </a:solidFill>
+                <a:latin typeface="Calibri" pitchFamily="34" charset="0"/>
+                <a:ea typeface="Calibri" pitchFamily="34" charset="-122"/>
+                <a:cs typeface="Calibri" pitchFamily="34" charset="-120"/>
+              </a:rPr>
+              <a:t>Constraints enforced: flight time · fuel · altitude band (100–3000 m; altitude scales radar exposure)</a:t>
+            </a:r>
+            <a:endParaRPr lang="en-US" sz="1100" dirty="0"/>
           </a:p>
         </p:txBody>
       </p:sp>

</xml_diff>

<commit_message>
Docs + deck: cover terrain masking, 3D, Pareto/survival, robust, mission builder
- README highlights + advanced-capabilities section (27 tests)
- ARCHITECTURE: new sections 5a/5b/5c (terrain+3D, survival/Pareto/robust, mission builder)
- DEMO_SCRIPT: advanced-capabilities beat
- Deck: new 'Advanced capabilities' slide, Almaty theatre label, updated results/counts

Co-Authored-By: Claude Opus 4.8 <noreply@anthropic.com>
</commit_message>
<xml_diff>
--- a/docs/UAV_DSS_Deck.pptx
+++ b/docs/UAV_DSS_Deck.pptx
@@ -13,9 +13,10 @@
     <p:sldId id="261" r:id="rId7"/>
     <p:sldId id="262" r:id="rId8"/>
     <p:sldId id="263" r:id="rId9"/>
+    <p:sldId id="264" r:id="rId10"/>
   </p:sldIdLst>
   <p:notesMasterIdLst>
-    <p:notesMasterId r:id="rId10"/>
+    <p:notesMasterId r:id="rId11"/>
   </p:notesMasterIdLst>
   <p:sldSz cx="12192000" cy="6858000"/>
   <p:notesSz cx="6858000" cy="12192000"/>
@@ -1726,6 +1727,94 @@
 </p:notes>
 </file>
 
+<file path=ppt/notesSlides/notesSlide9.xml><?xml version="1.0" encoding="utf-8"?>
+<p:notes xmlns:a="http://schemas.openxmlformats.org/drawingml/2006/main" xmlns:r="http://schemas.openxmlformats.org/officeDocument/2006/relationships" xmlns:p="http://schemas.openxmlformats.org/presentationml/2006/main">
+  <p:cSld>
+    <p:spTree>
+      <p:nvGrpSpPr>
+        <p:cNvPr id="1" name=""/>
+        <p:cNvGrpSpPr/>
+        <p:nvPr/>
+      </p:nvGrpSpPr>
+      <p:grpSpPr>
+        <a:xfrm>
+          <a:off x="0" y="0"/>
+          <a:ext cx="0" cy="0"/>
+          <a:chOff x="0" y="0"/>
+          <a:chExt cx="0" cy="0"/>
+        </a:xfrm>
+      </p:grpSpPr>
+      <p:sp>
+        <p:nvSpPr>
+          <p:cNvPr id="2" name="Slide Image Placeholder 1"/>
+          <p:cNvSpPr>
+            <a:spLocks noGrp="1" noRot="1" noChangeAspect="1"/>
+          </p:cNvSpPr>
+          <p:nvPr>
+            <p:ph type="sldImg"/>
+          </p:nvPr>
+        </p:nvSpPr>
+        <p:spPr/>
+      </p:sp>
+      <p:sp>
+        <p:nvSpPr>
+          <p:cNvPr id="3" name="Notes Placeholder 2"/>
+          <p:cNvSpPr>
+            <a:spLocks noGrp="1"/>
+          </p:cNvSpPr>
+          <p:nvPr>
+            <p:ph type="body" idx="1"/>
+          </p:nvPr>
+        </p:nvSpPr>
+        <p:spPr/>
+        <p:txBody>
+          <a:bodyPr/>
+          <a:lstStyle/>
+          <a:p>
+            <a:r>
+              <a:rPr lang="en-US" dirty="0"/>
+              <a:t/>
+            </a:r>
+            <a:endParaRPr lang="en-US" dirty="0"/>
+          </a:p>
+        </p:txBody>
+      </p:sp>
+      <p:sp>
+        <p:nvSpPr>
+          <p:cNvPr id="4" name="Slide Number Placeholder 3"/>
+          <p:cNvSpPr>
+            <a:spLocks noGrp="1"/>
+          </p:cNvSpPr>
+          <p:nvPr>
+            <p:ph type="sldNum" sz="quarter" idx="10"/>
+          </p:nvPr>
+        </p:nvSpPr>
+        <p:spPr/>
+        <p:txBody>
+          <a:bodyPr/>
+          <a:lstStyle/>
+          <a:p>
+            <a:fld id="{F7021451-1387-4CA6-816F-3879F97B5CBC}" type="slidenum">
+              <a:rPr lang="en-US"/>
+              <a:t>9</a:t>
+            </a:fld>
+            <a:endParaRPr lang="en-US"/>
+          </a:p>
+        </p:txBody>
+      </p:sp>
+    </p:spTree>
+    <p:extLst>
+      <p:ext uri="{BB962C8B-B14F-4D97-AF65-F5344CB8AC3E}">
+        <p14:creationId xmlns:p14="http://schemas.microsoft.com/office/powerpoint/2010/main" val="1024086991"/>
+      </p:ext>
+    </p:extLst>
+  </p:cSld>
+  <p:clrMapOvr>
+    <a:masterClrMapping/>
+  </p:clrMapOvr>
+</p:notes>
+</file>
+
 <file path=ppt/slideLayouts/slideLayout1.xml><?xml version="1.0" encoding="utf-8"?>
 <p:sldLayout xmlns:a="http://schemas.openxmlformats.org/drawingml/2006/main" xmlns:r="http://schemas.openxmlformats.org/officeDocument/2006/relationships" xmlns:p="http://schemas.openxmlformats.org/presentationml/2006/main" preserve="1">
   <p:cSld name="DEFAULT">
@@ -3035,7 +3124,7 @@
                 <a:ea typeface="Calibri" pitchFamily="34" charset="-122"/>
                 <a:cs typeface="Calibri" pitchFamily="34" charset="-120"/>
               </a:rPr>
-              <a:t>Working prototype · 21 passing tests · runs from one command</a:t>
+              <a:t>Working prototype · 27 passing tests · runs from one command</a:t>
             </a:r>
             <a:endParaRPr lang="en-US" sz="1300" dirty="0"/>
           </a:p>
@@ -6469,7 +6558,7 @@
         <p:spPr>
           <a:xfrm>
             <a:off x="1005840" y="1956816"/>
-            <a:ext cx="5943600" cy="274320"/>
+            <a:ext cx="6035040" cy="274320"/>
           </a:xfrm>
           <a:prstGeom prst="rect">
             <a:avLst/>
@@ -6493,7 +6582,7 @@
                 <a:ea typeface="Arial" pitchFamily="34" charset="-122"/>
                 <a:cs typeface="Arial" pitchFamily="34" charset="-120"/>
               </a:rPr>
-              <a:t>THEATRE · ASTANA REGION, KAZAKHSTAN</a:t>
+              <a:t>THEATRE · ALMATY REGION, KAZAKHSTAN (MOUNTAINOUS)</a:t>
             </a:r>
             <a:endParaRPr lang="en-US" sz="1000" dirty="0"/>
           </a:p>
@@ -7563,7 +7652,7 @@
                 <a:ea typeface="Arial" pitchFamily="34" charset="-122"/>
                 <a:cs typeface="Arial" pitchFamily="34" charset="-120"/>
               </a:rPr>
-              <a:t>UNDER THE HOOD</a:t>
+              <a:t>BEYOND THE BASELINE</a:t>
             </a:r>
             <a:endParaRPr lang="en-US" sz="1200" dirty="0"/>
           </a:p>
@@ -7602,7 +7691,7 @@
                 <a:ea typeface="Arial" pitchFamily="34" charset="-122"/>
                 <a:cs typeface="Arial" pitchFamily="34" charset="-120"/>
               </a:rPr>
-              <a:t>Architecture, stack &amp; security</a:t>
+              <a:t>Advanced capabilities</a:t>
             </a:r>
             <a:endParaRPr lang="en-US" sz="3400" dirty="0"/>
           </a:p>
@@ -7616,12 +7705,12 @@
         </p:nvSpPr>
         <p:spPr>
           <a:xfrm>
-            <a:off x="822960" y="1828800"/>
-            <a:ext cx="3291840" cy="2834640"/>
+            <a:off x="822960" y="1920240"/>
+            <a:ext cx="3291840" cy="1874520"/>
           </a:xfrm>
           <a:prstGeom prst="roundRect">
             <a:avLst>
-              <a:gd name="adj" fmla="val 2903"/>
+              <a:gd name="adj" fmla="val 4390"/>
             </a:avLst>
           </a:prstGeom>
           <a:solidFill>
@@ -7650,16 +7739,14 @@
         </p:nvSpPr>
         <p:spPr>
           <a:xfrm>
-            <a:off x="1097280" y="2057400"/>
-            <a:ext cx="1371600" cy="457200"/>
-          </a:xfrm>
-          <a:prstGeom prst="roundRect">
-            <a:avLst>
-              <a:gd name="adj" fmla="val 16000"/>
-            </a:avLst>
-          </a:prstGeom>
-          <a:solidFill>
-            <a:srgbClr val="4DA3FF"/>
+            <a:off x="1097280" y="2176272"/>
+            <a:ext cx="566928" cy="566928"/>
+          </a:xfrm>
+          <a:prstGeom prst="ellipse">
+            <a:avLst/>
+          </a:prstGeom>
+          <a:solidFill>
+            <a:srgbClr val="33D171"/>
           </a:solidFill>
           <a:ln/>
         </p:spPr>
@@ -7672,8 +7759,8 @@
         </p:nvSpPr>
         <p:spPr>
           <a:xfrm>
-            <a:off x="1097280" y="2057400"/>
-            <a:ext cx="1371600" cy="457200"/>
+            <a:off x="1097280" y="2176272"/>
+            <a:ext cx="566928" cy="566928"/>
           </a:xfrm>
           <a:prstGeom prst="rect">
             <a:avLst/>
@@ -7689,7 +7776,7 @@
               <a:buNone/>
             </a:pPr>
             <a:r>
-              <a:rPr lang="en-US" sz="1400" b="1" dirty="0">
+              <a:rPr lang="en-US" sz="1500" b="1" dirty="0">
                 <a:solidFill>
                   <a:srgbClr val="0B1220"/>
                 </a:solidFill>
@@ -7697,31 +7784,50 @@
                 <a:ea typeface="Arial" pitchFamily="34" charset="-122"/>
                 <a:cs typeface="Arial" pitchFamily="34" charset="-120"/>
               </a:rPr>
-              <a:t>Backend</a:t>
-            </a:r>
-            <a:endParaRPr lang="en-US" sz="1400" dirty="0"/>
-          </a:p>
-        </p:txBody>
-      </p:sp>
-      <p:sp>
-        <p:nvSpPr>
-          <p:cNvPr id="7" name="Shape 5"/>
-          <p:cNvSpPr/>
-          <p:nvPr/>
-        </p:nvSpPr>
-        <p:spPr>
-          <a:xfrm>
-            <a:off x="1115568" y="2798064"/>
-            <a:ext cx="91440" cy="91440"/>
-          </a:xfrm>
-          <a:prstGeom prst="ellipse">
-            <a:avLst/>
-          </a:prstGeom>
-          <a:solidFill>
-            <a:srgbClr val="4DA3FF"/>
-          </a:solidFill>
-          <a:ln/>
-        </p:spPr>
+              <a:t>LOS</a:t>
+            </a:r>
+            <a:endParaRPr lang="en-US" sz="1500" dirty="0"/>
+          </a:p>
+        </p:txBody>
+      </p:sp>
+      <p:sp>
+        <p:nvSpPr>
+          <p:cNvPr id="7" name="Text 5"/>
+          <p:cNvSpPr txBox="1"/>
+          <p:nvPr/>
+        </p:nvSpPr>
+        <p:spPr>
+          <a:xfrm>
+            <a:off x="1783080" y="2231136"/>
+            <a:ext cx="2194560" cy="457200"/>
+          </a:xfrm>
+          <a:prstGeom prst="rect">
+            <a:avLst/>
+          </a:prstGeom>
+          <a:noFill/>
+          <a:ln/>
+        </p:spPr>
+        <p:txBody>
+          <a:bodyPr wrap="square" lIns="0" tIns="0" rIns="0" bIns="0" rtlCol="0" anchor="ctr"/>
+          <a:lstStyle/>
+          <a:p>
+            <a:pPr indent="0" marL="0">
+              <a:buNone/>
+            </a:pPr>
+            <a:r>
+              <a:rPr lang="en-US" sz="1600" b="1" dirty="0">
+                <a:solidFill>
+                  <a:srgbClr val="E8EEF7"/>
+                </a:solidFill>
+                <a:latin typeface="Arial" pitchFamily="34" charset="0"/>
+                <a:ea typeface="Arial" pitchFamily="34" charset="-122"/>
+                <a:cs typeface="Arial" pitchFamily="34" charset="-120"/>
+              </a:rPr>
+              <a:t>Terrain masking</a:t>
+            </a:r>
+            <a:endParaRPr lang="en-US" sz="1600" dirty="0"/>
+          </a:p>
+        </p:txBody>
       </p:sp>
       <p:sp>
         <p:nvSpPr>
@@ -7731,8 +7837,8 @@
         </p:nvSpPr>
         <p:spPr>
           <a:xfrm>
-            <a:off x="1325880" y="2743200"/>
-            <a:ext cx="2651760" cy="411480"/>
+            <a:off x="1097280" y="2880360"/>
+            <a:ext cx="2788920" cy="822960"/>
           </a:xfrm>
           <a:prstGeom prst="rect">
             <a:avLst/>
@@ -7750,13 +7856,13 @@
             <a:r>
               <a:rPr lang="en-US" sz="1250" dirty="0">
                 <a:solidFill>
-                  <a:srgbClr val="E8EEF7"/>
+                  <a:srgbClr val="90A4C4"/>
                 </a:solidFill>
                 <a:latin typeface="Calibri" pitchFamily="34" charset="0"/>
                 <a:ea typeface="Calibri" pitchFamily="34" charset="-122"/>
                 <a:cs typeface="Calibri" pitchFamily="34" charset="-120"/>
               </a:rPr>
-              <a:t>FastAPI REST + WebSocket</a:t>
+              <a:t>Real-relief DEM + radar line-of-sight viewsheds — the UAV hides behind ridges</a:t>
             </a:r>
             <a:endParaRPr lang="en-US" sz="1250" dirty="0"/>
           </a:p>
@@ -7770,189 +7876,12 @@
         </p:nvSpPr>
         <p:spPr>
           <a:xfrm>
-            <a:off x="1115568" y="3255264"/>
-            <a:ext cx="91440" cy="91440"/>
-          </a:xfrm>
-          <a:prstGeom prst="ellipse">
-            <a:avLst/>
-          </a:prstGeom>
-          <a:solidFill>
-            <a:srgbClr val="4DA3FF"/>
-          </a:solidFill>
-          <a:ln/>
-        </p:spPr>
-      </p:sp>
-      <p:sp>
-        <p:nvSpPr>
-          <p:cNvPr id="10" name="Text 8"/>
-          <p:cNvSpPr txBox="1"/>
-          <p:nvPr/>
-        </p:nvSpPr>
-        <p:spPr>
-          <a:xfrm>
-            <a:off x="1325880" y="3200400"/>
-            <a:ext cx="2651760" cy="411480"/>
-          </a:xfrm>
-          <a:prstGeom prst="rect">
-            <a:avLst/>
-          </a:prstGeom>
-          <a:noFill/>
-          <a:ln/>
-        </p:spPr>
-        <p:txBody>
-          <a:bodyPr wrap="square" lIns="0" tIns="0" rIns="0" bIns="0" rtlCol="0" anchor="ctr"/>
-          <a:lstStyle/>
-          <a:p>
-            <a:pPr indent="0" marL="0">
-              <a:buNone/>
-            </a:pPr>
-            <a:r>
-              <a:rPr lang="en-US" sz="1250" dirty="0">
-                <a:solidFill>
-                  <a:srgbClr val="E8EEF7"/>
-                </a:solidFill>
-                <a:latin typeface="Calibri" pitchFamily="34" charset="0"/>
-                <a:ea typeface="Calibri" pitchFamily="34" charset="-122"/>
-                <a:cs typeface="Calibri" pitchFamily="34" charset="-120"/>
-              </a:rPr>
-              <a:t>NumPy vectorized cost field</a:t>
-            </a:r>
-            <a:endParaRPr lang="en-US" sz="1250" dirty="0"/>
-          </a:p>
-        </p:txBody>
-      </p:sp>
-      <p:sp>
-        <p:nvSpPr>
-          <p:cNvPr id="11" name="Shape 9"/>
-          <p:cNvSpPr/>
-          <p:nvPr/>
-        </p:nvSpPr>
-        <p:spPr>
-          <a:xfrm>
-            <a:off x="1115568" y="3712464"/>
-            <a:ext cx="91440" cy="91440"/>
-          </a:xfrm>
-          <a:prstGeom prst="ellipse">
-            <a:avLst/>
-          </a:prstGeom>
-          <a:solidFill>
-            <a:srgbClr val="4DA3FF"/>
-          </a:solidFill>
-          <a:ln/>
-        </p:spPr>
-      </p:sp>
-      <p:sp>
-        <p:nvSpPr>
-          <p:cNvPr id="12" name="Text 10"/>
-          <p:cNvSpPr txBox="1"/>
-          <p:nvPr/>
-        </p:nvSpPr>
-        <p:spPr>
-          <a:xfrm>
-            <a:off x="1325880" y="3657600"/>
-            <a:ext cx="2651760" cy="411480"/>
-          </a:xfrm>
-          <a:prstGeom prst="rect">
-            <a:avLst/>
-          </a:prstGeom>
-          <a:noFill/>
-          <a:ln/>
-        </p:spPr>
-        <p:txBody>
-          <a:bodyPr wrap="square" lIns="0" tIns="0" rIns="0" bIns="0" rtlCol="0" anchor="ctr"/>
-          <a:lstStyle/>
-          <a:p>
-            <a:pPr indent="0" marL="0">
-              <a:buNone/>
-            </a:pPr>
-            <a:r>
-              <a:rPr lang="en-US" sz="1250" dirty="0">
-                <a:solidFill>
-                  <a:srgbClr val="E8EEF7"/>
-                </a:solidFill>
-                <a:latin typeface="Calibri" pitchFamily="34" charset="0"/>
-                <a:ea typeface="Calibri" pitchFamily="34" charset="-122"/>
-                <a:cs typeface="Calibri" pitchFamily="34" charset="-120"/>
-              </a:rPr>
-              <a:t>Per-session live missions</a:t>
-            </a:r>
-            <a:endParaRPr lang="en-US" sz="1250" dirty="0"/>
-          </a:p>
-        </p:txBody>
-      </p:sp>
-      <p:sp>
-        <p:nvSpPr>
-          <p:cNvPr id="13" name="Shape 11"/>
-          <p:cNvSpPr/>
-          <p:nvPr/>
-        </p:nvSpPr>
-        <p:spPr>
-          <a:xfrm>
-            <a:off x="1115568" y="4169664"/>
-            <a:ext cx="91440" cy="91440"/>
-          </a:xfrm>
-          <a:prstGeom prst="ellipse">
-            <a:avLst/>
-          </a:prstGeom>
-          <a:solidFill>
-            <a:srgbClr val="4DA3FF"/>
-          </a:solidFill>
-          <a:ln/>
-        </p:spPr>
-      </p:sp>
-      <p:sp>
-        <p:nvSpPr>
-          <p:cNvPr id="14" name="Text 12"/>
-          <p:cNvSpPr txBox="1"/>
-          <p:nvPr/>
-        </p:nvSpPr>
-        <p:spPr>
-          <a:xfrm>
-            <a:off x="1325880" y="4114800"/>
-            <a:ext cx="2651760" cy="411480"/>
-          </a:xfrm>
-          <a:prstGeom prst="rect">
-            <a:avLst/>
-          </a:prstGeom>
-          <a:noFill/>
-          <a:ln/>
-        </p:spPr>
-        <p:txBody>
-          <a:bodyPr wrap="square" lIns="0" tIns="0" rIns="0" bIns="0" rtlCol="0" anchor="ctr"/>
-          <a:lstStyle/>
-          <a:p>
-            <a:pPr indent="0" marL="0">
-              <a:buNone/>
-            </a:pPr>
-            <a:r>
-              <a:rPr lang="en-US" sz="1250" dirty="0">
-                <a:solidFill>
-                  <a:srgbClr val="E8EEF7"/>
-                </a:solidFill>
-                <a:latin typeface="Calibri" pitchFamily="34" charset="0"/>
-                <a:ea typeface="Calibri" pitchFamily="34" charset="-122"/>
-                <a:cs typeface="Calibri" pitchFamily="34" charset="-120"/>
-              </a:rPr>
-              <a:t>Stateless, shardable</a:t>
-            </a:r>
-            <a:endParaRPr lang="en-US" sz="1250" dirty="0"/>
-          </a:p>
-        </p:txBody>
-      </p:sp>
-      <p:sp>
-        <p:nvSpPr>
-          <p:cNvPr id="15" name="Shape 13"/>
-          <p:cNvSpPr/>
-          <p:nvPr/>
-        </p:nvSpPr>
-        <p:spPr>
-          <a:xfrm>
-            <a:off x="4389120" y="1828800"/>
-            <a:ext cx="3291840" cy="2834640"/>
+            <a:off x="4389120" y="1920240"/>
+            <a:ext cx="3291840" cy="1874520"/>
           </a:xfrm>
           <a:prstGeom prst="roundRect">
             <a:avLst>
-              <a:gd name="adj" fmla="val 2903"/>
+              <a:gd name="adj" fmla="val 4390"/>
             </a:avLst>
           </a:prstGeom>
           <a:solidFill>
@@ -7975,36 +7904,34 @@
       </p:sp>
       <p:sp>
         <p:nvSpPr>
-          <p:cNvPr id="16" name="Shape 14"/>
+          <p:cNvPr id="10" name="Shape 8"/>
           <p:cNvSpPr/>
           <p:nvPr/>
         </p:nvSpPr>
         <p:spPr>
           <a:xfrm>
-            <a:off x="4663440" y="2057400"/>
-            <a:ext cx="1371600" cy="457200"/>
-          </a:xfrm>
-          <a:prstGeom prst="roundRect">
-            <a:avLst>
-              <a:gd name="adj" fmla="val 16000"/>
-            </a:avLst>
-          </a:prstGeom>
-          <a:solidFill>
-            <a:srgbClr val="33D171"/>
-          </a:solidFill>
-          <a:ln/>
-        </p:spPr>
-      </p:sp>
-      <p:sp>
-        <p:nvSpPr>
-          <p:cNvPr id="17" name="Text 15"/>
-          <p:cNvSpPr txBox="1"/>
-          <p:nvPr/>
-        </p:nvSpPr>
-        <p:spPr>
-          <a:xfrm>
-            <a:off x="4663440" y="2057400"/>
-            <a:ext cx="1371600" cy="457200"/>
+            <a:off x="4663440" y="2176272"/>
+            <a:ext cx="566928" cy="566928"/>
+          </a:xfrm>
+          <a:prstGeom prst="ellipse">
+            <a:avLst/>
+          </a:prstGeom>
+          <a:solidFill>
+            <a:srgbClr val="4DA3FF"/>
+          </a:solidFill>
+          <a:ln/>
+        </p:spPr>
+      </p:sp>
+      <p:sp>
+        <p:nvSpPr>
+          <p:cNvPr id="11" name="Text 9"/>
+          <p:cNvSpPr txBox="1"/>
+          <p:nvPr/>
+        </p:nvSpPr>
+        <p:spPr>
+          <a:xfrm>
+            <a:off x="4663440" y="2176272"/>
+            <a:ext cx="566928" cy="566928"/>
           </a:xfrm>
           <a:prstGeom prst="rect">
             <a:avLst/>
@@ -8020,7 +7947,7 @@
               <a:buNone/>
             </a:pPr>
             <a:r>
-              <a:rPr lang="en-US" sz="1400" b="1" dirty="0">
+              <a:rPr lang="en-US" sz="1500" b="1" dirty="0">
                 <a:solidFill>
                   <a:srgbClr val="0B1220"/>
                 </a:solidFill>
@@ -8028,42 +7955,61 @@
                 <a:ea typeface="Arial" pitchFamily="34" charset="-122"/>
                 <a:cs typeface="Arial" pitchFamily="34" charset="-120"/>
               </a:rPr>
-              <a:t>Intelligence</a:t>
-            </a:r>
-            <a:endParaRPr lang="en-US" sz="1400" dirty="0"/>
-          </a:p>
-        </p:txBody>
-      </p:sp>
-      <p:sp>
-        <p:nvSpPr>
-          <p:cNvPr id="18" name="Shape 16"/>
-          <p:cNvSpPr/>
-          <p:nvPr/>
-        </p:nvSpPr>
-        <p:spPr>
-          <a:xfrm>
-            <a:off x="4681728" y="2798064"/>
-            <a:ext cx="91440" cy="91440"/>
-          </a:xfrm>
-          <a:prstGeom prst="ellipse">
-            <a:avLst/>
-          </a:prstGeom>
-          <a:solidFill>
-            <a:srgbClr val="33D171"/>
-          </a:solidFill>
-          <a:ln/>
-        </p:spPr>
-      </p:sp>
-      <p:sp>
-        <p:nvSpPr>
-          <p:cNvPr id="19" name="Text 17"/>
-          <p:cNvSpPr txBox="1"/>
-          <p:nvPr/>
-        </p:nvSpPr>
-        <p:spPr>
-          <a:xfrm>
-            <a:off x="4892040" y="2743200"/>
-            <a:ext cx="2651760" cy="411480"/>
+              <a:t>3D</a:t>
+            </a:r>
+            <a:endParaRPr lang="en-US" sz="1500" dirty="0"/>
+          </a:p>
+        </p:txBody>
+      </p:sp>
+      <p:sp>
+        <p:nvSpPr>
+          <p:cNvPr id="12" name="Text 10"/>
+          <p:cNvSpPr txBox="1"/>
+          <p:nvPr/>
+        </p:nvSpPr>
+        <p:spPr>
+          <a:xfrm>
+            <a:off x="5349240" y="2231136"/>
+            <a:ext cx="2194560" cy="457200"/>
+          </a:xfrm>
+          <a:prstGeom prst="rect">
+            <a:avLst/>
+          </a:prstGeom>
+          <a:noFill/>
+          <a:ln/>
+        </p:spPr>
+        <p:txBody>
+          <a:bodyPr wrap="square" lIns="0" tIns="0" rIns="0" bIns="0" rtlCol="0" anchor="ctr"/>
+          <a:lstStyle/>
+          <a:p>
+            <a:pPr indent="0" marL="0">
+              <a:buNone/>
+            </a:pPr>
+            <a:r>
+              <a:rPr lang="en-US" sz="1600" b="1" dirty="0">
+                <a:solidFill>
+                  <a:srgbClr val="E8EEF7"/>
+                </a:solidFill>
+                <a:latin typeface="Arial" pitchFamily="34" charset="0"/>
+                <a:ea typeface="Arial" pitchFamily="34" charset="-122"/>
+                <a:cs typeface="Arial" pitchFamily="34" charset="-120"/>
+              </a:rPr>
+              <a:t>3D nap-of-earth</a:t>
+            </a:r>
+            <a:endParaRPr lang="en-US" sz="1600" dirty="0"/>
+          </a:p>
+        </p:txBody>
+      </p:sp>
+      <p:sp>
+        <p:nvSpPr>
+          <p:cNvPr id="13" name="Text 11"/>
+          <p:cNvSpPr txBox="1"/>
+          <p:nvPr/>
+        </p:nvSpPr>
+        <p:spPr>
+          <a:xfrm>
+            <a:off x="4663440" y="2880360"/>
+            <a:ext cx="2788920" cy="822960"/>
           </a:xfrm>
           <a:prstGeom prst="rect">
             <a:avLst/>
@@ -8081,13 +8027,13 @@
             <a:r>
               <a:rPr lang="en-US" sz="1250" dirty="0">
                 <a:solidFill>
-                  <a:srgbClr val="E8EEF7"/>
+                  <a:srgbClr val="90A4C4"/>
                 </a:solidFill>
                 <a:latin typeface="Calibri" pitchFamily="34" charset="0"/>
                 <a:ea typeface="Calibri" pitchFamily="34" charset="-122"/>
                 <a:cs typeface="Calibri" pitchFamily="34" charset="-120"/>
               </a:rPr>
-              <a:t>PyTorch CNN nowcaster</a:t>
+              <a:t>Altitude is optimised (200 / 700 / 1500 m AGL); fly low for cover, climb only when needed</a:t>
             </a:r>
             <a:endParaRPr lang="en-US" sz="1250" dirty="0"/>
           </a:p>
@@ -8095,195 +8041,18 @@
       </p:sp>
       <p:sp>
         <p:nvSpPr>
-          <p:cNvPr id="20" name="Shape 18"/>
+          <p:cNvPr id="14" name="Shape 12"/>
           <p:cNvSpPr/>
           <p:nvPr/>
         </p:nvSpPr>
         <p:spPr>
           <a:xfrm>
-            <a:off x="4681728" y="3255264"/>
-            <a:ext cx="91440" cy="91440"/>
-          </a:xfrm>
-          <a:prstGeom prst="ellipse">
-            <a:avLst/>
-          </a:prstGeom>
-          <a:solidFill>
-            <a:srgbClr val="33D171"/>
-          </a:solidFill>
-          <a:ln/>
-        </p:spPr>
-      </p:sp>
-      <p:sp>
-        <p:nvSpPr>
-          <p:cNvPr id="21" name="Text 19"/>
-          <p:cNvSpPr txBox="1"/>
-          <p:nvPr/>
-        </p:nvSpPr>
-        <p:spPr>
-          <a:xfrm>
-            <a:off x="4892040" y="3200400"/>
-            <a:ext cx="2651760" cy="411480"/>
-          </a:xfrm>
-          <a:prstGeom prst="rect">
-            <a:avLst/>
-          </a:prstGeom>
-          <a:noFill/>
-          <a:ln/>
-        </p:spPr>
-        <p:txBody>
-          <a:bodyPr wrap="square" lIns="0" tIns="0" rIns="0" bIns="0" rtlCol="0" anchor="ctr"/>
-          <a:lstStyle/>
-          <a:p>
-            <a:pPr indent="0" marL="0">
-              <a:buNone/>
-            </a:pPr>
-            <a:r>
-              <a:rPr lang="en-US" sz="1250" dirty="0">
-                <a:solidFill>
-                  <a:srgbClr val="E8EEF7"/>
-                </a:solidFill>
-                <a:latin typeface="Calibri" pitchFamily="34" charset="0"/>
-                <a:ea typeface="Calibri" pitchFamily="34" charset="-122"/>
-                <a:cs typeface="Calibri" pitchFamily="34" charset="-120"/>
-              </a:rPr>
-              <a:t>scikit-learn GBM classifier</a:t>
-            </a:r>
-            <a:endParaRPr lang="en-US" sz="1250" dirty="0"/>
-          </a:p>
-        </p:txBody>
-      </p:sp>
-      <p:sp>
-        <p:nvSpPr>
-          <p:cNvPr id="22" name="Shape 20"/>
-          <p:cNvSpPr/>
-          <p:nvPr/>
-        </p:nvSpPr>
-        <p:spPr>
-          <a:xfrm>
-            <a:off x="4681728" y="3712464"/>
-            <a:ext cx="91440" cy="91440"/>
-          </a:xfrm>
-          <a:prstGeom prst="ellipse">
-            <a:avLst/>
-          </a:prstGeom>
-          <a:solidFill>
-            <a:srgbClr val="33D171"/>
-          </a:solidFill>
-          <a:ln/>
-        </p:spPr>
-      </p:sp>
-      <p:sp>
-        <p:nvSpPr>
-          <p:cNvPr id="23" name="Text 21"/>
-          <p:cNvSpPr txBox="1"/>
-          <p:nvPr/>
-        </p:nvSpPr>
-        <p:spPr>
-          <a:xfrm>
-            <a:off x="4892040" y="3657600"/>
-            <a:ext cx="2651760" cy="411480"/>
-          </a:xfrm>
-          <a:prstGeom prst="rect">
-            <a:avLst/>
-          </a:prstGeom>
-          <a:noFill/>
-          <a:ln/>
-        </p:spPr>
-        <p:txBody>
-          <a:bodyPr wrap="square" lIns="0" tIns="0" rIns="0" bIns="0" rtlCol="0" anchor="ctr"/>
-          <a:lstStyle/>
-          <a:p>
-            <a:pPr indent="0" marL="0">
-              <a:buNone/>
-            </a:pPr>
-            <a:r>
-              <a:rPr lang="en-US" sz="1250" dirty="0">
-                <a:solidFill>
-                  <a:srgbClr val="E8EEF7"/>
-                </a:solidFill>
-                <a:latin typeface="Calibri" pitchFamily="34" charset="0"/>
-                <a:ea typeface="Calibri" pitchFamily="34" charset="-122"/>
-                <a:cs typeface="Calibri" pitchFamily="34" charset="-120"/>
-              </a:rPr>
-              <a:t>A* + D* Lite optimizer</a:t>
-            </a:r>
-            <a:endParaRPr lang="en-US" sz="1250" dirty="0"/>
-          </a:p>
-        </p:txBody>
-      </p:sp>
-      <p:sp>
-        <p:nvSpPr>
-          <p:cNvPr id="24" name="Shape 22"/>
-          <p:cNvSpPr/>
-          <p:nvPr/>
-        </p:nvSpPr>
-        <p:spPr>
-          <a:xfrm>
-            <a:off x="4681728" y="4169664"/>
-            <a:ext cx="91440" cy="91440"/>
-          </a:xfrm>
-          <a:prstGeom prst="ellipse">
-            <a:avLst/>
-          </a:prstGeom>
-          <a:solidFill>
-            <a:srgbClr val="33D171"/>
-          </a:solidFill>
-          <a:ln/>
-        </p:spPr>
-      </p:sp>
-      <p:sp>
-        <p:nvSpPr>
-          <p:cNvPr id="25" name="Text 23"/>
-          <p:cNvSpPr txBox="1"/>
-          <p:nvPr/>
-        </p:nvSpPr>
-        <p:spPr>
-          <a:xfrm>
-            <a:off x="4892040" y="4114800"/>
-            <a:ext cx="2651760" cy="411480"/>
-          </a:xfrm>
-          <a:prstGeom prst="rect">
-            <a:avLst/>
-          </a:prstGeom>
-          <a:noFill/>
-          <a:ln/>
-        </p:spPr>
-        <p:txBody>
-          <a:bodyPr wrap="square" lIns="0" tIns="0" rIns="0" bIns="0" rtlCol="0" anchor="ctr"/>
-          <a:lstStyle/>
-          <a:p>
-            <a:pPr indent="0" marL="0">
-              <a:buNone/>
-            </a:pPr>
-            <a:r>
-              <a:rPr lang="en-US" sz="1250" dirty="0">
-                <a:solidFill>
-                  <a:srgbClr val="E8EEF7"/>
-                </a:solidFill>
-                <a:latin typeface="Calibri" pitchFamily="34" charset="0"/>
-                <a:ea typeface="Calibri" pitchFamily="34" charset="-122"/>
-                <a:cs typeface="Calibri" pitchFamily="34" charset="-120"/>
-              </a:rPr>
-              <a:t>Multi-objective weighting</a:t>
-            </a:r>
-            <a:endParaRPr lang="en-US" sz="1250" dirty="0"/>
-          </a:p>
-        </p:txBody>
-      </p:sp>
-      <p:sp>
-        <p:nvSpPr>
-          <p:cNvPr id="26" name="Shape 24"/>
-          <p:cNvSpPr/>
-          <p:nvPr/>
-        </p:nvSpPr>
-        <p:spPr>
-          <a:xfrm>
-            <a:off x="7955280" y="1828800"/>
-            <a:ext cx="3291840" cy="2834640"/>
+            <a:off x="7955280" y="1920240"/>
+            <a:ext cx="3291840" cy="1874520"/>
           </a:xfrm>
           <a:prstGeom prst="roundRect">
             <a:avLst>
-              <a:gd name="adj" fmla="val 2903"/>
+              <a:gd name="adj" fmla="val 4390"/>
             </a:avLst>
           </a:prstGeom>
           <a:solidFill>
@@ -8306,19 +8075,17 @@
       </p:sp>
       <p:sp>
         <p:nvSpPr>
-          <p:cNvPr id="27" name="Shape 25"/>
+          <p:cNvPr id="15" name="Shape 13"/>
           <p:cNvSpPr/>
           <p:nvPr/>
         </p:nvSpPr>
         <p:spPr>
           <a:xfrm>
-            <a:off x="8229600" y="2057400"/>
-            <a:ext cx="1371600" cy="457200"/>
-          </a:xfrm>
-          <a:prstGeom prst="roundRect">
-            <a:avLst>
-              <a:gd name="adj" fmla="val 16000"/>
-            </a:avLst>
+            <a:off x="8229600" y="2176272"/>
+            <a:ext cx="566928" cy="566928"/>
+          </a:xfrm>
+          <a:prstGeom prst="ellipse">
+            <a:avLst/>
           </a:prstGeom>
           <a:solidFill>
             <a:srgbClr val="F5B942"/>
@@ -8328,14 +8095,14 @@
       </p:sp>
       <p:sp>
         <p:nvSpPr>
-          <p:cNvPr id="28" name="Text 26"/>
-          <p:cNvSpPr txBox="1"/>
-          <p:nvPr/>
-        </p:nvSpPr>
-        <p:spPr>
-          <a:xfrm>
-            <a:off x="8229600" y="2057400"/>
-            <a:ext cx="1371600" cy="457200"/>
+          <p:cNvPr id="16" name="Text 14"/>
+          <p:cNvSpPr txBox="1"/>
+          <p:nvPr/>
+        </p:nvSpPr>
+        <p:spPr>
+          <a:xfrm>
+            <a:off x="8229600" y="2176272"/>
+            <a:ext cx="566928" cy="566928"/>
           </a:xfrm>
           <a:prstGeom prst="rect">
             <a:avLst/>
@@ -8351,7 +8118,7 @@
               <a:buNone/>
             </a:pPr>
             <a:r>
-              <a:rPr lang="en-US" sz="1400" b="1" dirty="0">
+              <a:rPr lang="en-US" sz="1500" b="1" dirty="0">
                 <a:solidFill>
                   <a:srgbClr val="0B1220"/>
                 </a:solidFill>
@@ -8359,42 +8126,61 @@
                 <a:ea typeface="Arial" pitchFamily="34" charset="-122"/>
                 <a:cs typeface="Arial" pitchFamily="34" charset="-120"/>
               </a:rPr>
-              <a:t>Frontend</a:t>
-            </a:r>
-            <a:endParaRPr lang="en-US" sz="1400" dirty="0"/>
-          </a:p>
-        </p:txBody>
-      </p:sp>
-      <p:sp>
-        <p:nvSpPr>
-          <p:cNvPr id="29" name="Shape 27"/>
-          <p:cNvSpPr/>
-          <p:nvPr/>
-        </p:nvSpPr>
-        <p:spPr>
-          <a:xfrm>
-            <a:off x="8247888" y="2798064"/>
-            <a:ext cx="91440" cy="91440"/>
-          </a:xfrm>
-          <a:prstGeom prst="ellipse">
-            <a:avLst/>
-          </a:prstGeom>
-          <a:solidFill>
-            <a:srgbClr val="F5B942"/>
-          </a:solidFill>
-          <a:ln/>
-        </p:spPr>
-      </p:sp>
-      <p:sp>
-        <p:nvSpPr>
-          <p:cNvPr id="30" name="Text 28"/>
-          <p:cNvSpPr txBox="1"/>
-          <p:nvPr/>
-        </p:nvSpPr>
-        <p:spPr>
-          <a:xfrm>
-            <a:off x="8458200" y="2743200"/>
-            <a:ext cx="2651760" cy="411480"/>
+              <a:t>P</a:t>
+            </a:r>
+            <a:endParaRPr lang="en-US" sz="1500" dirty="0"/>
+          </a:p>
+        </p:txBody>
+      </p:sp>
+      <p:sp>
+        <p:nvSpPr>
+          <p:cNvPr id="17" name="Text 15"/>
+          <p:cNvSpPr txBox="1"/>
+          <p:nvPr/>
+        </p:nvSpPr>
+        <p:spPr>
+          <a:xfrm>
+            <a:off x="8915400" y="2231136"/>
+            <a:ext cx="2194560" cy="457200"/>
+          </a:xfrm>
+          <a:prstGeom prst="rect">
+            <a:avLst/>
+          </a:prstGeom>
+          <a:noFill/>
+          <a:ln/>
+        </p:spPr>
+        <p:txBody>
+          <a:bodyPr wrap="square" lIns="0" tIns="0" rIns="0" bIns="0" rtlCol="0" anchor="ctr"/>
+          <a:lstStyle/>
+          <a:p>
+            <a:pPr indent="0" marL="0">
+              <a:buNone/>
+            </a:pPr>
+            <a:r>
+              <a:rPr lang="en-US" sz="1600" b="1" dirty="0">
+                <a:solidFill>
+                  <a:srgbClr val="E8EEF7"/>
+                </a:solidFill>
+                <a:latin typeface="Arial" pitchFamily="34" charset="0"/>
+                <a:ea typeface="Arial" pitchFamily="34" charset="-122"/>
+                <a:cs typeface="Arial" pitchFamily="34" charset="-120"/>
+              </a:rPr>
+              <a:t>Survival probability</a:t>
+            </a:r>
+            <a:endParaRPr lang="en-US" sz="1600" dirty="0"/>
+          </a:p>
+        </p:txBody>
+      </p:sp>
+      <p:sp>
+        <p:nvSpPr>
+          <p:cNvPr id="18" name="Text 16"/>
+          <p:cNvSpPr txBox="1"/>
+          <p:nvPr/>
+        </p:nvSpPr>
+        <p:spPr>
+          <a:xfrm>
+            <a:off x="8229600" y="2880360"/>
+            <a:ext cx="2788920" cy="822960"/>
           </a:xfrm>
           <a:prstGeom prst="rect">
             <a:avLst/>
@@ -8412,13 +8198,13 @@
             <a:r>
               <a:rPr lang="en-US" sz="1250" dirty="0">
                 <a:solidFill>
-                  <a:srgbClr val="E8EEF7"/>
+                  <a:srgbClr val="90A4C4"/>
                 </a:solidFill>
                 <a:latin typeface="Calibri" pitchFamily="34" charset="0"/>
                 <a:ea typeface="Calibri" pitchFamily="34" charset="-122"/>
                 <a:cs typeface="Calibri" pitchFamily="34" charset="-120"/>
               </a:rPr>
-              <a:t>Leaflet operator dashboard</a:t>
+              <a:t>Cumulative P(detected) from a hazard-rate model — 0.70 low vs 0.89 exposed</a:t>
             </a:r>
             <a:endParaRPr lang="en-US" sz="1250" dirty="0"/>
           </a:p>
@@ -8426,199 +8212,22 @@
       </p:sp>
       <p:sp>
         <p:nvSpPr>
-          <p:cNvPr id="31" name="Shape 29"/>
+          <p:cNvPr id="19" name="Shape 17"/>
           <p:cNvSpPr/>
           <p:nvPr/>
         </p:nvSpPr>
         <p:spPr>
           <a:xfrm>
-            <a:off x="8247888" y="3255264"/>
-            <a:ext cx="91440" cy="91440"/>
-          </a:xfrm>
-          <a:prstGeom prst="ellipse">
-            <a:avLst/>
-          </a:prstGeom>
-          <a:solidFill>
-            <a:srgbClr val="F5B942"/>
-          </a:solidFill>
-          <a:ln/>
-        </p:spPr>
-      </p:sp>
-      <p:sp>
-        <p:nvSpPr>
-          <p:cNvPr id="32" name="Text 30"/>
-          <p:cNvSpPr txBox="1"/>
-          <p:nvPr/>
-        </p:nvSpPr>
-        <p:spPr>
-          <a:xfrm>
-            <a:off x="8458200" y="3200400"/>
-            <a:ext cx="2651760" cy="411480"/>
-          </a:xfrm>
-          <a:prstGeom prst="rect">
-            <a:avLst/>
-          </a:prstGeom>
-          <a:noFill/>
-          <a:ln/>
-        </p:spPr>
-        <p:txBody>
-          <a:bodyPr wrap="square" lIns="0" tIns="0" rIns="0" bIns="0" rtlCol="0" anchor="ctr"/>
-          <a:lstStyle/>
-          <a:p>
-            <a:pPr indent="0" marL="0">
-              <a:buNone/>
-            </a:pPr>
-            <a:r>
-              <a:rPr lang="en-US" sz="1250" dirty="0">
-                <a:solidFill>
-                  <a:srgbClr val="E8EEF7"/>
-                </a:solidFill>
-                <a:latin typeface="Calibri" pitchFamily="34" charset="0"/>
-                <a:ea typeface="Calibri" pitchFamily="34" charset="-122"/>
-                <a:cs typeface="Calibri" pitchFamily="34" charset="-120"/>
-              </a:rPr>
-              <a:t>Danger heatmap + threat rings</a:t>
-            </a:r>
-            <a:endParaRPr lang="en-US" sz="1250" dirty="0"/>
-          </a:p>
-        </p:txBody>
-      </p:sp>
-      <p:sp>
-        <p:nvSpPr>
-          <p:cNvPr id="33" name="Shape 31"/>
-          <p:cNvSpPr/>
-          <p:nvPr/>
-        </p:nvSpPr>
-        <p:spPr>
-          <a:xfrm>
-            <a:off x="8247888" y="3712464"/>
-            <a:ext cx="91440" cy="91440"/>
-          </a:xfrm>
-          <a:prstGeom prst="ellipse">
-            <a:avLst/>
-          </a:prstGeom>
-          <a:solidFill>
-            <a:srgbClr val="F5B942"/>
-          </a:solidFill>
-          <a:ln/>
-        </p:spPr>
-      </p:sp>
-      <p:sp>
-        <p:nvSpPr>
-          <p:cNvPr id="34" name="Text 32"/>
-          <p:cNvSpPr txBox="1"/>
-          <p:nvPr/>
-        </p:nvSpPr>
-        <p:spPr>
-          <a:xfrm>
-            <a:off x="8458200" y="3657600"/>
-            <a:ext cx="2651760" cy="411480"/>
-          </a:xfrm>
-          <a:prstGeom prst="rect">
-            <a:avLst/>
-          </a:prstGeom>
-          <a:noFill/>
-          <a:ln/>
-        </p:spPr>
-        <p:txBody>
-          <a:bodyPr wrap="square" lIns="0" tIns="0" rIns="0" bIns="0" rtlCol="0" anchor="ctr"/>
-          <a:lstStyle/>
-          <a:p>
-            <a:pPr indent="0" marL="0">
-              <a:buNone/>
-            </a:pPr>
-            <a:r>
-              <a:rPr lang="en-US" sz="1250" dirty="0">
-                <a:solidFill>
-                  <a:srgbClr val="E8EEF7"/>
-                </a:solidFill>
-                <a:latin typeface="Calibri" pitchFamily="34" charset="0"/>
-                <a:ea typeface="Calibri" pitchFamily="34" charset="-122"/>
-                <a:cs typeface="Calibri" pitchFamily="34" charset="-120"/>
-              </a:rPr>
-              <a:t>Priority sliders, live clock</a:t>
-            </a:r>
-            <a:endParaRPr lang="en-US" sz="1250" dirty="0"/>
-          </a:p>
-        </p:txBody>
-      </p:sp>
-      <p:sp>
-        <p:nvSpPr>
-          <p:cNvPr id="35" name="Shape 33"/>
-          <p:cNvSpPr/>
-          <p:nvPr/>
-        </p:nvSpPr>
-        <p:spPr>
-          <a:xfrm>
-            <a:off x="8247888" y="4169664"/>
-            <a:ext cx="91440" cy="91440"/>
-          </a:xfrm>
-          <a:prstGeom prst="ellipse">
-            <a:avLst/>
-          </a:prstGeom>
-          <a:solidFill>
-            <a:srgbClr val="F5B942"/>
-          </a:solidFill>
-          <a:ln/>
-        </p:spPr>
-      </p:sp>
-      <p:sp>
-        <p:nvSpPr>
-          <p:cNvPr id="36" name="Text 34"/>
-          <p:cNvSpPr txBox="1"/>
-          <p:nvPr/>
-        </p:nvSpPr>
-        <p:spPr>
-          <a:xfrm>
-            <a:off x="8458200" y="4114800"/>
-            <a:ext cx="2651760" cy="411480"/>
-          </a:xfrm>
-          <a:prstGeom prst="rect">
-            <a:avLst/>
-          </a:prstGeom>
-          <a:noFill/>
-          <a:ln/>
-        </p:spPr>
-        <p:txBody>
-          <a:bodyPr wrap="square" lIns="0" tIns="0" rIns="0" bIns="0" rtlCol="0" anchor="ctr"/>
-          <a:lstStyle/>
-          <a:p>
-            <a:pPr indent="0" marL="0">
-              <a:buNone/>
-            </a:pPr>
-            <a:r>
-              <a:rPr lang="en-US" sz="1250" dirty="0">
-                <a:solidFill>
-                  <a:srgbClr val="E8EEF7"/>
-                </a:solidFill>
-                <a:latin typeface="Calibri" pitchFamily="34" charset="0"/>
-                <a:ea typeface="Calibri" pitchFamily="34" charset="-122"/>
-                <a:cs typeface="Calibri" pitchFamily="34" charset="-120"/>
-              </a:rPr>
-              <a:t>Zero-build, one command</a:t>
-            </a:r>
-            <a:endParaRPr lang="en-US" sz="1250" dirty="0"/>
-          </a:p>
-        </p:txBody>
-      </p:sp>
-      <p:sp>
-        <p:nvSpPr>
-          <p:cNvPr id="37" name="Shape 35"/>
-          <p:cNvSpPr/>
-          <p:nvPr/>
-        </p:nvSpPr>
-        <p:spPr>
-          <a:xfrm>
-            <a:off x="822960" y="4892040"/>
-            <a:ext cx="10515600" cy="1371600"/>
+            <a:off x="822960" y="4069080"/>
+            <a:ext cx="3291840" cy="1874520"/>
           </a:xfrm>
           <a:prstGeom prst="roundRect">
             <a:avLst>
-              <a:gd name="adj" fmla="val 6000"/>
+              <a:gd name="adj" fmla="val 4390"/>
             </a:avLst>
           </a:prstGeom>
           <a:solidFill>
-            <a:srgbClr val="1E2C49"/>
+            <a:srgbClr val="16223A"/>
           </a:solidFill>
           <a:ln w="12700">
             <a:solidFill>
@@ -8637,69 +8246,89 @@
       </p:sp>
       <p:sp>
         <p:nvSpPr>
-          <p:cNvPr id="38" name="Text 36"/>
-          <p:cNvSpPr txBox="1"/>
-          <p:nvPr/>
-        </p:nvSpPr>
-        <p:spPr>
-          <a:xfrm>
-            <a:off x="1097280" y="5074920"/>
-            <a:ext cx="3657600" cy="320040"/>
-          </a:xfrm>
-          <a:prstGeom prst="rect">
-            <a:avLst/>
-          </a:prstGeom>
-          <a:noFill/>
-          <a:ln/>
-        </p:spPr>
-        <p:txBody>
-          <a:bodyPr wrap="square" lIns="0" tIns="0" rIns="0" bIns="0" rtlCol="0" anchor="ctr"/>
-          <a:lstStyle/>
-          <a:p>
-            <a:pPr indent="0" marL="0">
-              <a:buNone/>
-            </a:pPr>
-            <a:r>
-              <a:rPr lang="en-US" sz="1400" b="1" dirty="0">
-                <a:solidFill>
-                  <a:srgbClr val="FF5D5D"/>
+          <p:cNvPr id="20" name="Shape 18"/>
+          <p:cNvSpPr/>
+          <p:nvPr/>
+        </p:nvSpPr>
+        <p:spPr>
+          <a:xfrm>
+            <a:off x="1097280" y="4325112"/>
+            <a:ext cx="566928" cy="566928"/>
+          </a:xfrm>
+          <a:prstGeom prst="ellipse">
+            <a:avLst/>
+          </a:prstGeom>
+          <a:solidFill>
+            <a:srgbClr val="4DA3FF"/>
+          </a:solidFill>
+          <a:ln/>
+        </p:spPr>
+      </p:sp>
+      <p:sp>
+        <p:nvSpPr>
+          <p:cNvPr id="21" name="Text 19"/>
+          <p:cNvSpPr txBox="1"/>
+          <p:nvPr/>
+        </p:nvSpPr>
+        <p:spPr>
+          <a:xfrm>
+            <a:off x="1097280" y="4325112"/>
+            <a:ext cx="566928" cy="566928"/>
+          </a:xfrm>
+          <a:prstGeom prst="rect">
+            <a:avLst/>
+          </a:prstGeom>
+          <a:noFill/>
+          <a:ln/>
+        </p:spPr>
+        <p:txBody>
+          <a:bodyPr wrap="square" lIns="0" tIns="0" rIns="0" bIns="0" rtlCol="0" anchor="ctr"/>
+          <a:lstStyle/>
+          <a:p>
+            <a:pPr algn="ctr" indent="0" marL="0">
+              <a:buNone/>
+            </a:pPr>
+            <a:r>
+              <a:rPr lang="en-US" sz="1500" b="1" dirty="0">
+                <a:solidFill>
+                  <a:srgbClr val="0B1220"/>
                 </a:solidFill>
                 <a:latin typeface="Arial" pitchFamily="34" charset="0"/>
                 <a:ea typeface="Arial" pitchFamily="34" charset="-122"/>
                 <a:cs typeface="Arial" pitchFamily="34" charset="-120"/>
               </a:rPr>
-              <a:t>Security (brief §7)</a:t>
-            </a:r>
-            <a:endParaRPr lang="en-US" sz="1400" dirty="0"/>
-          </a:p>
-        </p:txBody>
-      </p:sp>
-      <p:sp>
-        <p:nvSpPr>
-          <p:cNvPr id="39" name="Text 37"/>
-          <p:cNvSpPr txBox="1"/>
-          <p:nvPr/>
-        </p:nvSpPr>
-        <p:spPr>
-          <a:xfrm>
-            <a:off x="1097280" y="5440680"/>
-            <a:ext cx="3291840" cy="320040"/>
-          </a:xfrm>
-          <a:prstGeom prst="rect">
-            <a:avLst/>
-          </a:prstGeom>
-          <a:noFill/>
-          <a:ln/>
-        </p:spPr>
-        <p:txBody>
-          <a:bodyPr wrap="square" lIns="0" tIns="0" rIns="0" bIns="0" rtlCol="0" anchor="ctr"/>
-          <a:lstStyle/>
-          <a:p>
-            <a:pPr indent="0" marL="0">
-              <a:buNone/>
-            </a:pPr>
-            <a:r>
-              <a:rPr lang="en-US" sz="1400" b="1" dirty="0">
+              <a:t>◆</a:t>
+            </a:r>
+            <a:endParaRPr lang="en-US" sz="1500" dirty="0"/>
+          </a:p>
+        </p:txBody>
+      </p:sp>
+      <p:sp>
+        <p:nvSpPr>
+          <p:cNvPr id="22" name="Text 20"/>
+          <p:cNvSpPr txBox="1"/>
+          <p:nvPr/>
+        </p:nvSpPr>
+        <p:spPr>
+          <a:xfrm>
+            <a:off x="1783080" y="4379976"/>
+            <a:ext cx="2194560" cy="457200"/>
+          </a:xfrm>
+          <a:prstGeom prst="rect">
+            <a:avLst/>
+          </a:prstGeom>
+          <a:noFill/>
+          <a:ln/>
+        </p:spPr>
+        <p:txBody>
+          <a:bodyPr wrap="square" lIns="0" tIns="0" rIns="0" bIns="0" rtlCol="0" anchor="ctr"/>
+          <a:lstStyle/>
+          <a:p>
+            <a:pPr indent="0" marL="0">
+              <a:buNone/>
+            </a:pPr>
+            <a:r>
+              <a:rPr lang="en-US" sz="1600" b="1" dirty="0">
                 <a:solidFill>
                   <a:srgbClr val="E8EEF7"/>
                 </a:solidFill>
@@ -8707,38 +8336,38 @@
                 <a:ea typeface="Arial" pitchFamily="34" charset="-122"/>
                 <a:cs typeface="Arial" pitchFamily="34" charset="-120"/>
               </a:rPr>
-              <a:t>JWT auth</a:t>
-            </a:r>
-            <a:endParaRPr lang="en-US" sz="1400" dirty="0"/>
-          </a:p>
-        </p:txBody>
-      </p:sp>
-      <p:sp>
-        <p:nvSpPr>
-          <p:cNvPr id="40" name="Text 38"/>
-          <p:cNvSpPr txBox="1"/>
-          <p:nvPr/>
-        </p:nvSpPr>
-        <p:spPr>
-          <a:xfrm>
-            <a:off x="1097280" y="5760720"/>
-            <a:ext cx="3291840" cy="411480"/>
-          </a:xfrm>
-          <a:prstGeom prst="rect">
-            <a:avLst/>
-          </a:prstGeom>
-          <a:noFill/>
-          <a:ln/>
-        </p:spPr>
-        <p:txBody>
-          <a:bodyPr wrap="square" lIns="0" tIns="0" rIns="0" bIns="0" rtlCol="0" anchor="ctr"/>
-          <a:lstStyle/>
-          <a:p>
-            <a:pPr indent="0" marL="0">
-              <a:buNone/>
-            </a:pPr>
-            <a:r>
-              <a:rPr lang="en-US" sz="1200" dirty="0">
+              <a:t>Pareto trade-offs</a:t>
+            </a:r>
+            <a:endParaRPr lang="en-US" sz="1600" dirty="0"/>
+          </a:p>
+        </p:txBody>
+      </p:sp>
+      <p:sp>
+        <p:nvSpPr>
+          <p:cNvPr id="23" name="Text 21"/>
+          <p:cNvSpPr txBox="1"/>
+          <p:nvPr/>
+        </p:nvSpPr>
+        <p:spPr>
+          <a:xfrm>
+            <a:off x="1097280" y="5029200"/>
+            <a:ext cx="2788920" cy="822960"/>
+          </a:xfrm>
+          <a:prstGeom prst="rect">
+            <a:avLst/>
+          </a:prstGeom>
+          <a:noFill/>
+          <a:ln/>
+        </p:spPr>
+        <p:txBody>
+          <a:bodyPr wrap="square" lIns="0" tIns="0" rIns="0" bIns="0" rtlCol="0" anchor="ctr"/>
+          <a:lstStyle/>
+          <a:p>
+            <a:pPr indent="0" marL="0">
+              <a:buNone/>
+            </a:pPr>
+            <a:r>
+              <a:rPr lang="en-US" sz="1250" dirty="0">
                 <a:solidFill>
                   <a:srgbClr val="90A4C4"/>
                 </a:solidFill>
@@ -8746,77 +8375,170 @@
                 <a:ea typeface="Calibri" pitchFamily="34" charset="-122"/>
                 <a:cs typeface="Calibri" pitchFamily="34" charset="-120"/>
               </a:rPr>
-              <a:t>hashed operator credential (PBKDF2)</a:t>
-            </a:r>
-            <a:endParaRPr lang="en-US" sz="1200" dirty="0"/>
-          </a:p>
-        </p:txBody>
-      </p:sp>
-      <p:sp>
-        <p:nvSpPr>
-          <p:cNvPr id="41" name="Text 39"/>
-          <p:cNvSpPr txBox="1"/>
-          <p:nvPr/>
-        </p:nvSpPr>
-        <p:spPr>
-          <a:xfrm>
-            <a:off x="4526280" y="5440680"/>
-            <a:ext cx="3291840" cy="320040"/>
-          </a:xfrm>
-          <a:prstGeom prst="rect">
-            <a:avLst/>
-          </a:prstGeom>
-          <a:noFill/>
-          <a:ln/>
-        </p:spPr>
-        <p:txBody>
-          <a:bodyPr wrap="square" lIns="0" tIns="0" rIns="0" bIns="0" rtlCol="0" anchor="ctr"/>
-          <a:lstStyle/>
-          <a:p>
-            <a:pPr indent="0" marL="0">
-              <a:buNone/>
-            </a:pPr>
-            <a:r>
-              <a:rPr lang="en-US" sz="1400" b="1" dirty="0">
-                <a:solidFill>
-                  <a:srgbClr val="E8EEF7"/>
+              <a:t>The full time-vs-detection front, not three presets — operator picks the point</a:t>
+            </a:r>
+            <a:endParaRPr lang="en-US" sz="1250" dirty="0"/>
+          </a:p>
+        </p:txBody>
+      </p:sp>
+      <p:sp>
+        <p:nvSpPr>
+          <p:cNvPr id="24" name="Shape 22"/>
+          <p:cNvSpPr/>
+          <p:nvPr/>
+        </p:nvSpPr>
+        <p:spPr>
+          <a:xfrm>
+            <a:off x="4389120" y="4069080"/>
+            <a:ext cx="3291840" cy="1874520"/>
+          </a:xfrm>
+          <a:prstGeom prst="roundRect">
+            <a:avLst>
+              <a:gd name="adj" fmla="val 4390"/>
+            </a:avLst>
+          </a:prstGeom>
+          <a:solidFill>
+            <a:srgbClr val="16223A"/>
+          </a:solidFill>
+          <a:ln w="12700">
+            <a:solidFill>
+              <a:srgbClr val="2A3A5C"/>
+            </a:solidFill>
+            <a:prstDash val="solid"/>
+          </a:ln>
+          <a:effectLst>
+            <a:outerShdw sx="100000" sy="100000" kx="0" ky="0" algn="bl" rotWithShape="0" blurRad="101600" dist="38100" dir="5400000">
+              <a:srgbClr val="000000">
+                <a:alpha val="35000"/>
+              </a:srgbClr>
+            </a:outerShdw>
+          </a:effectLst>
+        </p:spPr>
+      </p:sp>
+      <p:sp>
+        <p:nvSpPr>
+          <p:cNvPr id="25" name="Shape 23"/>
+          <p:cNvSpPr/>
+          <p:nvPr/>
+        </p:nvSpPr>
+        <p:spPr>
+          <a:xfrm>
+            <a:off x="4663440" y="4325112"/>
+            <a:ext cx="566928" cy="566928"/>
+          </a:xfrm>
+          <a:prstGeom prst="ellipse">
+            <a:avLst/>
+          </a:prstGeom>
+          <a:solidFill>
+            <a:srgbClr val="33D171"/>
+          </a:solidFill>
+          <a:ln/>
+        </p:spPr>
+      </p:sp>
+      <p:sp>
+        <p:nvSpPr>
+          <p:cNvPr id="26" name="Text 24"/>
+          <p:cNvSpPr txBox="1"/>
+          <p:nvPr/>
+        </p:nvSpPr>
+        <p:spPr>
+          <a:xfrm>
+            <a:off x="4663440" y="4325112"/>
+            <a:ext cx="566928" cy="566928"/>
+          </a:xfrm>
+          <a:prstGeom prst="rect">
+            <a:avLst/>
+          </a:prstGeom>
+          <a:noFill/>
+          <a:ln/>
+        </p:spPr>
+        <p:txBody>
+          <a:bodyPr wrap="square" lIns="0" tIns="0" rIns="0" bIns="0" rtlCol="0" anchor="ctr"/>
+          <a:lstStyle/>
+          <a:p>
+            <a:pPr algn="ctr" indent="0" marL="0">
+              <a:buNone/>
+            </a:pPr>
+            <a:r>
+              <a:rPr lang="en-US" sz="1500" b="1" dirty="0">
+                <a:solidFill>
+                  <a:srgbClr val="0B1220"/>
                 </a:solidFill>
                 <a:latin typeface="Arial" pitchFamily="34" charset="0"/>
                 <a:ea typeface="Arial" pitchFamily="34" charset="-122"/>
                 <a:cs typeface="Arial" pitchFamily="34" charset="-120"/>
               </a:rPr>
-              <a:t>AES / Fernet</a:t>
-            </a:r>
-            <a:endParaRPr lang="en-US" sz="1400" dirty="0"/>
-          </a:p>
-        </p:txBody>
-      </p:sp>
-      <p:sp>
-        <p:nvSpPr>
-          <p:cNvPr id="42" name="Text 40"/>
-          <p:cNvSpPr txBox="1"/>
-          <p:nvPr/>
-        </p:nvSpPr>
-        <p:spPr>
-          <a:xfrm>
-            <a:off x="4526280" y="5760720"/>
-            <a:ext cx="3291840" cy="411480"/>
-          </a:xfrm>
-          <a:prstGeom prst="rect">
-            <a:avLst/>
-          </a:prstGeom>
-          <a:noFill/>
-          <a:ln/>
-        </p:spPr>
-        <p:txBody>
-          <a:bodyPr wrap="square" lIns="0" tIns="0" rIns="0" bIns="0" rtlCol="0" anchor="ctr"/>
-          <a:lstStyle/>
-          <a:p>
-            <a:pPr indent="0" marL="0">
-              <a:buNone/>
-            </a:pPr>
-            <a:r>
-              <a:rPr lang="en-US" sz="1200" dirty="0">
+              <a:t>±</a:t>
+            </a:r>
+            <a:endParaRPr lang="en-US" sz="1500" dirty="0"/>
+          </a:p>
+        </p:txBody>
+      </p:sp>
+      <p:sp>
+        <p:nvSpPr>
+          <p:cNvPr id="27" name="Text 25"/>
+          <p:cNvSpPr txBox="1"/>
+          <p:nvPr/>
+        </p:nvSpPr>
+        <p:spPr>
+          <a:xfrm>
+            <a:off x="5349240" y="4379976"/>
+            <a:ext cx="2194560" cy="457200"/>
+          </a:xfrm>
+          <a:prstGeom prst="rect">
+            <a:avLst/>
+          </a:prstGeom>
+          <a:noFill/>
+          <a:ln/>
+        </p:spPr>
+        <p:txBody>
+          <a:bodyPr wrap="square" lIns="0" tIns="0" rIns="0" bIns="0" rtlCol="0" anchor="ctr"/>
+          <a:lstStyle/>
+          <a:p>
+            <a:pPr indent="0" marL="0">
+              <a:buNone/>
+            </a:pPr>
+            <a:r>
+              <a:rPr lang="en-US" sz="1600" b="1" dirty="0">
+                <a:solidFill>
+                  <a:srgbClr val="E8EEF7"/>
+                </a:solidFill>
+                <a:latin typeface="Arial" pitchFamily="34" charset="0"/>
+                <a:ea typeface="Arial" pitchFamily="34" charset="-122"/>
+                <a:cs typeface="Arial" pitchFamily="34" charset="-120"/>
+              </a:rPr>
+              <a:t>Robust planning</a:t>
+            </a:r>
+            <a:endParaRPr lang="en-US" sz="1600" dirty="0"/>
+          </a:p>
+        </p:txBody>
+      </p:sp>
+      <p:sp>
+        <p:nvSpPr>
+          <p:cNvPr id="28" name="Text 26"/>
+          <p:cNvSpPr txBox="1"/>
+          <p:nvPr/>
+        </p:nvSpPr>
+        <p:spPr>
+          <a:xfrm>
+            <a:off x="4663440" y="5029200"/>
+            <a:ext cx="2788920" cy="822960"/>
+          </a:xfrm>
+          <a:prstGeom prst="rect">
+            <a:avLst/>
+          </a:prstGeom>
+          <a:noFill/>
+          <a:ln/>
+        </p:spPr>
+        <p:txBody>
+          <a:bodyPr wrap="square" lIns="0" tIns="0" rIns="0" bIns="0" rtlCol="0" anchor="ctr"/>
+          <a:lstStyle/>
+          <a:p>
+            <a:pPr indent="0" marL="0">
+              <a:buNone/>
+            </a:pPr>
+            <a:r>
+              <a:rPr lang="en-US" sz="1250" dirty="0">
                 <a:solidFill>
                   <a:srgbClr val="90A4C4"/>
                 </a:solidFill>
@@ -8824,77 +8546,170 @@
                 <a:ea typeface="Calibri" pitchFamily="34" charset="-122"/>
                 <a:cs typeface="Calibri" pitchFamily="34" charset="-120"/>
               </a:rPr>
-              <a:t>encryption of stored scenarios</a:t>
-            </a:r>
-            <a:endParaRPr lang="en-US" sz="1200" dirty="0"/>
-          </a:p>
-        </p:txBody>
-      </p:sp>
-      <p:sp>
-        <p:nvSpPr>
-          <p:cNvPr id="43" name="Text 41"/>
-          <p:cNvSpPr txBox="1"/>
-          <p:nvPr/>
-        </p:nvSpPr>
-        <p:spPr>
-          <a:xfrm>
-            <a:off x="7955280" y="5440680"/>
-            <a:ext cx="3291840" cy="320040"/>
-          </a:xfrm>
-          <a:prstGeom prst="rect">
-            <a:avLst/>
-          </a:prstGeom>
-          <a:noFill/>
-          <a:ln/>
-        </p:spPr>
-        <p:txBody>
-          <a:bodyPr wrap="square" lIns="0" tIns="0" rIns="0" bIns="0" rtlCol="0" anchor="ctr"/>
-          <a:lstStyle/>
-          <a:p>
-            <a:pPr indent="0" marL="0">
-              <a:buNone/>
-            </a:pPr>
-            <a:r>
-              <a:rPr lang="en-US" sz="1400" b="1" dirty="0">
-                <a:solidFill>
-                  <a:srgbClr val="E8EEF7"/>
+              <a:t>Optimise against the worst case of current + 6-min ML forecast</a:t>
+            </a:r>
+            <a:endParaRPr lang="en-US" sz="1250" dirty="0"/>
+          </a:p>
+        </p:txBody>
+      </p:sp>
+      <p:sp>
+        <p:nvSpPr>
+          <p:cNvPr id="29" name="Shape 27"/>
+          <p:cNvSpPr/>
+          <p:nvPr/>
+        </p:nvSpPr>
+        <p:spPr>
+          <a:xfrm>
+            <a:off x="7955280" y="4069080"/>
+            <a:ext cx="3291840" cy="1874520"/>
+          </a:xfrm>
+          <a:prstGeom prst="roundRect">
+            <a:avLst>
+              <a:gd name="adj" fmla="val 4390"/>
+            </a:avLst>
+          </a:prstGeom>
+          <a:solidFill>
+            <a:srgbClr val="16223A"/>
+          </a:solidFill>
+          <a:ln w="12700">
+            <a:solidFill>
+              <a:srgbClr val="2A3A5C"/>
+            </a:solidFill>
+            <a:prstDash val="solid"/>
+          </a:ln>
+          <a:effectLst>
+            <a:outerShdw sx="100000" sy="100000" kx="0" ky="0" algn="bl" rotWithShape="0" blurRad="101600" dist="38100" dir="5400000">
+              <a:srgbClr val="000000">
+                <a:alpha val="35000"/>
+              </a:srgbClr>
+            </a:outerShdw>
+          </a:effectLst>
+        </p:spPr>
+      </p:sp>
+      <p:sp>
+        <p:nvSpPr>
+          <p:cNvPr id="30" name="Shape 28"/>
+          <p:cNvSpPr/>
+          <p:nvPr/>
+        </p:nvSpPr>
+        <p:spPr>
+          <a:xfrm>
+            <a:off x="8229600" y="4325112"/>
+            <a:ext cx="566928" cy="566928"/>
+          </a:xfrm>
+          <a:prstGeom prst="ellipse">
+            <a:avLst/>
+          </a:prstGeom>
+          <a:solidFill>
+            <a:srgbClr val="F5B942"/>
+          </a:solidFill>
+          <a:ln/>
+        </p:spPr>
+      </p:sp>
+      <p:sp>
+        <p:nvSpPr>
+          <p:cNvPr id="31" name="Text 29"/>
+          <p:cNvSpPr txBox="1"/>
+          <p:nvPr/>
+        </p:nvSpPr>
+        <p:spPr>
+          <a:xfrm>
+            <a:off x="8229600" y="4325112"/>
+            <a:ext cx="566928" cy="566928"/>
+          </a:xfrm>
+          <a:prstGeom prst="rect">
+            <a:avLst/>
+          </a:prstGeom>
+          <a:noFill/>
+          <a:ln/>
+        </p:spPr>
+        <p:txBody>
+          <a:bodyPr wrap="square" lIns="0" tIns="0" rIns="0" bIns="0" rtlCol="0" anchor="ctr"/>
+          <a:lstStyle/>
+          <a:p>
+            <a:pPr algn="ctr" indent="0" marL="0">
+              <a:buNone/>
+            </a:pPr>
+            <a:r>
+              <a:rPr lang="en-US" sz="1500" b="1" dirty="0">
+                <a:solidFill>
+                  <a:srgbClr val="0B1220"/>
                 </a:solidFill>
                 <a:latin typeface="Arial" pitchFamily="34" charset="0"/>
                 <a:ea typeface="Arial" pitchFamily="34" charset="-122"/>
                 <a:cs typeface="Arial" pitchFamily="34" charset="-120"/>
               </a:rPr>
-              <a:t>Env-var secrets</a:t>
-            </a:r>
-            <a:endParaRPr lang="en-US" sz="1400" dirty="0"/>
-          </a:p>
-        </p:txBody>
-      </p:sp>
-      <p:sp>
-        <p:nvSpPr>
-          <p:cNvPr id="44" name="Text 42"/>
-          <p:cNvSpPr txBox="1"/>
-          <p:nvPr/>
-        </p:nvSpPr>
-        <p:spPr>
-          <a:xfrm>
-            <a:off x="7955280" y="5760720"/>
-            <a:ext cx="3291840" cy="411480"/>
-          </a:xfrm>
-          <a:prstGeom prst="rect">
-            <a:avLst/>
-          </a:prstGeom>
-          <a:noFill/>
-          <a:ln/>
-        </p:spPr>
-        <p:txBody>
-          <a:bodyPr wrap="square" lIns="0" tIns="0" rIns="0" bIns="0" rtlCol="0" anchor="ctr"/>
-          <a:lstStyle/>
-          <a:p>
-            <a:pPr indent="0" marL="0">
-              <a:buNone/>
-            </a:pPr>
-            <a:r>
-              <a:rPr lang="en-US" sz="1200" dirty="0">
+              <a:t>+</a:t>
+            </a:r>
+            <a:endParaRPr lang="en-US" sz="1500" dirty="0"/>
+          </a:p>
+        </p:txBody>
+      </p:sp>
+      <p:sp>
+        <p:nvSpPr>
+          <p:cNvPr id="32" name="Text 30"/>
+          <p:cNvSpPr txBox="1"/>
+          <p:nvPr/>
+        </p:nvSpPr>
+        <p:spPr>
+          <a:xfrm>
+            <a:off x="8915400" y="4379976"/>
+            <a:ext cx="2194560" cy="457200"/>
+          </a:xfrm>
+          <a:prstGeom prst="rect">
+            <a:avLst/>
+          </a:prstGeom>
+          <a:noFill/>
+          <a:ln/>
+        </p:spPr>
+        <p:txBody>
+          <a:bodyPr wrap="square" lIns="0" tIns="0" rIns="0" bIns="0" rtlCol="0" anchor="ctr"/>
+          <a:lstStyle/>
+          <a:p>
+            <a:pPr indent="0" marL="0">
+              <a:buNone/>
+            </a:pPr>
+            <a:r>
+              <a:rPr lang="en-US" sz="1600" b="1" dirty="0">
+                <a:solidFill>
+                  <a:srgbClr val="E8EEF7"/>
+                </a:solidFill>
+                <a:latin typeface="Arial" pitchFamily="34" charset="0"/>
+                <a:ea typeface="Arial" pitchFamily="34" charset="-122"/>
+                <a:cs typeface="Arial" pitchFamily="34" charset="-120"/>
+              </a:rPr>
+              <a:t>Mission builder</a:t>
+            </a:r>
+            <a:endParaRPr lang="en-US" sz="1600" dirty="0"/>
+          </a:p>
+        </p:txBody>
+      </p:sp>
+      <p:sp>
+        <p:nvSpPr>
+          <p:cNvPr id="33" name="Text 31"/>
+          <p:cNvSpPr txBox="1"/>
+          <p:nvPr/>
+        </p:nvSpPr>
+        <p:spPr>
+          <a:xfrm>
+            <a:off x="8229600" y="5029200"/>
+            <a:ext cx="2788920" cy="822960"/>
+          </a:xfrm>
+          <a:prstGeom prst="rect">
+            <a:avLst/>
+          </a:prstGeom>
+          <a:noFill/>
+          <a:ln/>
+        </p:spPr>
+        <p:txBody>
+          <a:bodyPr wrap="square" lIns="0" tIns="0" rIns="0" bIns="0" rtlCol="0" anchor="ctr"/>
+          <a:lstStyle/>
+          <a:p>
+            <a:pPr indent="0" marL="0">
+              <a:buNone/>
+            </a:pPr>
+            <a:r>
+              <a:rPr lang="en-US" sz="1250" dirty="0">
                 <a:solidFill>
                   <a:srgbClr val="90A4C4"/>
                 </a:solidFill>
@@ -8902,7 +8717,46 @@
                 <a:ea typeface="Calibri" pitchFamily="34" charset="-122"/>
                 <a:cs typeface="Calibri" pitchFamily="34" charset="-120"/>
               </a:rPr>
-              <a:t>no plaintext keys in code</a:t>
+              <a:t>Click the map to place start, objective and waypoints</a:t>
+            </a:r>
+            <a:endParaRPr lang="en-US" sz="1250" dirty="0"/>
+          </a:p>
+        </p:txBody>
+      </p:sp>
+      <p:sp>
+        <p:nvSpPr>
+          <p:cNvPr id="34" name="Text 32"/>
+          <p:cNvSpPr txBox="1"/>
+          <p:nvPr/>
+        </p:nvSpPr>
+        <p:spPr>
+          <a:xfrm>
+            <a:off x="822960" y="6355080"/>
+            <a:ext cx="10515600" cy="320040"/>
+          </a:xfrm>
+          <a:prstGeom prst="rect">
+            <a:avLst/>
+          </a:prstGeom>
+          <a:noFill/>
+          <a:ln/>
+        </p:spPr>
+        <p:txBody>
+          <a:bodyPr wrap="square" lIns="0" tIns="0" rIns="0" bIns="0" rtlCol="0" anchor="ctr"/>
+          <a:lstStyle/>
+          <a:p>
+            <a:pPr indent="0" marL="0">
+              <a:buNone/>
+            </a:pPr>
+            <a:r>
+              <a:rPr lang="en-US" sz="1200" i="1" dirty="0">
+                <a:solidFill>
+                  <a:srgbClr val="4DA3FF"/>
+                </a:solidFill>
+                <a:latin typeface="Calibri" pitchFamily="34" charset="0"/>
+                <a:ea typeface="Calibri" pitchFamily="34" charset="-122"/>
+                <a:cs typeface="Calibri" pitchFamily="34" charset="-120"/>
+              </a:rPr>
+              <a:t>All within the brief's objective — route optimisation under weather &amp; air-defense — and validated by 27 tests.</a:t>
             </a:r>
             <a:endParaRPr lang="en-US" sz="1200" dirty="0"/>
           </a:p>
@@ -8948,7 +8802,7 @@
         </p:nvSpPr>
         <p:spPr>
           <a:xfrm>
-            <a:off x="822960" y="640080"/>
+            <a:off x="822960" y="548640"/>
             <a:ext cx="5486400" cy="274320"/>
           </a:xfrm>
           <a:prstGeom prst="rect">
@@ -8973,7 +8827,7 @@
                 <a:ea typeface="Arial" pitchFamily="34" charset="-122"/>
                 <a:cs typeface="Arial" pitchFamily="34" charset="-120"/>
               </a:rPr>
-              <a:t>RESULTS · MAPPED TO JUDGING CRITERIA</a:t>
+              <a:t>UNDER THE HOOD</a:t>
             </a:r>
             <a:endParaRPr lang="en-US" sz="1200" dirty="0"/>
           </a:p>
@@ -8987,24 +8841,24 @@
         </p:nvSpPr>
         <p:spPr>
           <a:xfrm>
-            <a:off x="777240" y="1005840"/>
-            <a:ext cx="10789920" cy="822960"/>
-          </a:xfrm>
-          <a:prstGeom prst="rect">
-            <a:avLst/>
-          </a:prstGeom>
-          <a:noFill/>
-          <a:ln/>
-        </p:spPr>
-        <p:txBody>
-          <a:bodyPr wrap="square" lIns="0" tIns="0" rIns="0" bIns="0" rtlCol="0" anchor="ctr"/>
-          <a:lstStyle/>
-          <a:p>
-            <a:pPr indent="0" marL="0">
-              <a:buNone/>
-            </a:pPr>
-            <a:r>
-              <a:rPr lang="en-US" sz="4000" b="1" dirty="0">
+            <a:off x="777240" y="868680"/>
+            <a:ext cx="10789920" cy="731520"/>
+          </a:xfrm>
+          <a:prstGeom prst="rect">
+            <a:avLst/>
+          </a:prstGeom>
+          <a:noFill/>
+          <a:ln/>
+        </p:spPr>
+        <p:txBody>
+          <a:bodyPr wrap="square" lIns="0" tIns="0" rIns="0" bIns="0" rtlCol="0" anchor="ctr"/>
+          <a:lstStyle/>
+          <a:p>
+            <a:pPr indent="0" marL="0">
+              <a:buNone/>
+            </a:pPr>
+            <a:r>
+              <a:rPr lang="en-US" sz="3400" b="1" dirty="0">
                 <a:solidFill>
                   <a:srgbClr val="E8EEF7"/>
                 </a:solidFill>
@@ -9012,9 +8866,9 @@
                 <a:ea typeface="Arial" pitchFamily="34" charset="-122"/>
                 <a:cs typeface="Arial" pitchFamily="34" charset="-120"/>
               </a:rPr>
-              <a:t>A complete, working prototype</a:t>
-            </a:r>
-            <a:endParaRPr lang="en-US" sz="4000" dirty="0"/>
+              <a:t>Architecture, stack &amp; security</a:t>
+            </a:r>
+            <a:endParaRPr lang="en-US" sz="3400" dirty="0"/>
           </a:p>
         </p:txBody>
       </p:sp>
@@ -9026,12 +8880,12 @@
         </p:nvSpPr>
         <p:spPr>
           <a:xfrm>
-            <a:off x="822960" y="2103120"/>
-            <a:ext cx="5074920" cy="914400"/>
+            <a:off x="822960" y="1828800"/>
+            <a:ext cx="3291840" cy="2834640"/>
           </a:xfrm>
           <a:prstGeom prst="roundRect">
             <a:avLst>
-              <a:gd name="adj" fmla="val 9000"/>
+              <a:gd name="adj" fmla="val 2903"/>
             </a:avLst>
           </a:prstGeom>
           <a:solidFill>
@@ -9060,14 +8914,16 @@
         </p:nvSpPr>
         <p:spPr>
           <a:xfrm>
-            <a:off x="1078992" y="2487168"/>
-            <a:ext cx="146304" cy="146304"/>
-          </a:xfrm>
-          <a:prstGeom prst="ellipse">
-            <a:avLst/>
-          </a:prstGeom>
-          <a:solidFill>
-            <a:srgbClr val="33D171"/>
+            <a:off x="1097280" y="2057400"/>
+            <a:ext cx="1371600" cy="457200"/>
+          </a:xfrm>
+          <a:prstGeom prst="roundRect">
+            <a:avLst>
+              <a:gd name="adj" fmla="val 16000"/>
+            </a:avLst>
+          </a:prstGeom>
+          <a:solidFill>
+            <a:srgbClr val="4DA3FF"/>
           </a:solidFill>
           <a:ln/>
         </p:spPr>
@@ -9080,47 +8936,67 @@
         </p:nvSpPr>
         <p:spPr>
           <a:xfrm>
-            <a:off x="1325880" y="2221992"/>
-            <a:ext cx="4480560" cy="365760"/>
-          </a:xfrm>
-          <a:prstGeom prst="rect">
-            <a:avLst/>
-          </a:prstGeom>
-          <a:noFill/>
-          <a:ln/>
-        </p:spPr>
-        <p:txBody>
-          <a:bodyPr wrap="square" lIns="0" tIns="0" rIns="0" bIns="0" rtlCol="0" anchor="ctr"/>
-          <a:lstStyle/>
-          <a:p>
-            <a:pPr indent="0" marL="0">
-              <a:buNone/>
-            </a:pPr>
-            <a:r>
-              <a:rPr lang="en-US" sz="1500" b="1" dirty="0">
-                <a:solidFill>
-                  <a:srgbClr val="E8EEF7"/>
+            <a:off x="1097280" y="2057400"/>
+            <a:ext cx="1371600" cy="457200"/>
+          </a:xfrm>
+          <a:prstGeom prst="rect">
+            <a:avLst/>
+          </a:prstGeom>
+          <a:noFill/>
+          <a:ln/>
+        </p:spPr>
+        <p:txBody>
+          <a:bodyPr wrap="square" lIns="0" tIns="0" rIns="0" bIns="0" rtlCol="0" anchor="ctr"/>
+          <a:lstStyle/>
+          <a:p>
+            <a:pPr algn="ctr" indent="0" marL="0">
+              <a:buNone/>
+            </a:pPr>
+            <a:r>
+              <a:rPr lang="en-US" sz="1400" b="1" dirty="0">
+                <a:solidFill>
+                  <a:srgbClr val="0B1220"/>
                 </a:solidFill>
                 <a:latin typeface="Arial" pitchFamily="34" charset="0"/>
                 <a:ea typeface="Arial" pitchFamily="34" charset="-122"/>
                 <a:cs typeface="Arial" pitchFamily="34" charset="-120"/>
               </a:rPr>
-              <a:t>Prediction accuracy</a:t>
-            </a:r>
-            <a:endParaRPr lang="en-US" sz="1500" dirty="0"/>
-          </a:p>
-        </p:txBody>
-      </p:sp>
-      <p:sp>
-        <p:nvSpPr>
-          <p:cNvPr id="7" name="Text 5"/>
-          <p:cNvSpPr txBox="1"/>
-          <p:nvPr/>
-        </p:nvSpPr>
-        <p:spPr>
-          <a:xfrm>
-            <a:off x="1325880" y="2578608"/>
-            <a:ext cx="4480560" cy="365760"/>
+              <a:t>Backend</a:t>
+            </a:r>
+            <a:endParaRPr lang="en-US" sz="1400" dirty="0"/>
+          </a:p>
+        </p:txBody>
+      </p:sp>
+      <p:sp>
+        <p:nvSpPr>
+          <p:cNvPr id="7" name="Shape 5"/>
+          <p:cNvSpPr/>
+          <p:nvPr/>
+        </p:nvSpPr>
+        <p:spPr>
+          <a:xfrm>
+            <a:off x="1115568" y="2798064"/>
+            <a:ext cx="91440" cy="91440"/>
+          </a:xfrm>
+          <a:prstGeom prst="ellipse">
+            <a:avLst/>
+          </a:prstGeom>
+          <a:solidFill>
+            <a:srgbClr val="4DA3FF"/>
+          </a:solidFill>
+          <a:ln/>
+        </p:spPr>
+      </p:sp>
+      <p:sp>
+        <p:nvSpPr>
+          <p:cNvPr id="8" name="Text 6"/>
+          <p:cNvSpPr txBox="1"/>
+          <p:nvPr/>
+        </p:nvSpPr>
+        <p:spPr>
+          <a:xfrm>
+            <a:off x="1325880" y="2743200"/>
+            <a:ext cx="2651760" cy="411480"/>
           </a:xfrm>
           <a:prstGeom prst="rect">
             <a:avLst/>
@@ -9138,13 +9014,13 @@
             <a:r>
               <a:rPr lang="en-US" sz="1250" dirty="0">
                 <a:solidFill>
-                  <a:srgbClr val="90A4C4"/>
+                  <a:srgbClr val="E8EEF7"/>
                 </a:solidFill>
                 <a:latin typeface="Calibri" pitchFamily="34" charset="0"/>
                 <a:ea typeface="Calibri" pitchFamily="34" charset="-122"/>
                 <a:cs typeface="Calibri" pitchFamily="34" charset="-120"/>
               </a:rPr>
-              <a:t>-39% weather RMSE · +22 pts AD (AUC 0.79)</a:t>
+              <a:t>FastAPI REST + WebSocket</a:t>
             </a:r>
             <a:endParaRPr lang="en-US" sz="1250" dirty="0"/>
           </a:p>
@@ -9152,18 +9028,195 @@
       </p:sp>
       <p:sp>
         <p:nvSpPr>
-          <p:cNvPr id="8" name="Shape 6"/>
+          <p:cNvPr id="9" name="Shape 7"/>
           <p:cNvSpPr/>
           <p:nvPr/>
         </p:nvSpPr>
         <p:spPr>
           <a:xfrm>
-            <a:off x="6172200" y="2103120"/>
-            <a:ext cx="5074920" cy="914400"/>
+            <a:off x="1115568" y="3255264"/>
+            <a:ext cx="91440" cy="91440"/>
+          </a:xfrm>
+          <a:prstGeom prst="ellipse">
+            <a:avLst/>
+          </a:prstGeom>
+          <a:solidFill>
+            <a:srgbClr val="4DA3FF"/>
+          </a:solidFill>
+          <a:ln/>
+        </p:spPr>
+      </p:sp>
+      <p:sp>
+        <p:nvSpPr>
+          <p:cNvPr id="10" name="Text 8"/>
+          <p:cNvSpPr txBox="1"/>
+          <p:nvPr/>
+        </p:nvSpPr>
+        <p:spPr>
+          <a:xfrm>
+            <a:off x="1325880" y="3200400"/>
+            <a:ext cx="2651760" cy="411480"/>
+          </a:xfrm>
+          <a:prstGeom prst="rect">
+            <a:avLst/>
+          </a:prstGeom>
+          <a:noFill/>
+          <a:ln/>
+        </p:spPr>
+        <p:txBody>
+          <a:bodyPr wrap="square" lIns="0" tIns="0" rIns="0" bIns="0" rtlCol="0" anchor="ctr"/>
+          <a:lstStyle/>
+          <a:p>
+            <a:pPr indent="0" marL="0">
+              <a:buNone/>
+            </a:pPr>
+            <a:r>
+              <a:rPr lang="en-US" sz="1250" dirty="0">
+                <a:solidFill>
+                  <a:srgbClr val="E8EEF7"/>
+                </a:solidFill>
+                <a:latin typeface="Calibri" pitchFamily="34" charset="0"/>
+                <a:ea typeface="Calibri" pitchFamily="34" charset="-122"/>
+                <a:cs typeface="Calibri" pitchFamily="34" charset="-120"/>
+              </a:rPr>
+              <a:t>NumPy vectorized cost field</a:t>
+            </a:r>
+            <a:endParaRPr lang="en-US" sz="1250" dirty="0"/>
+          </a:p>
+        </p:txBody>
+      </p:sp>
+      <p:sp>
+        <p:nvSpPr>
+          <p:cNvPr id="11" name="Shape 9"/>
+          <p:cNvSpPr/>
+          <p:nvPr/>
+        </p:nvSpPr>
+        <p:spPr>
+          <a:xfrm>
+            <a:off x="1115568" y="3712464"/>
+            <a:ext cx="91440" cy="91440"/>
+          </a:xfrm>
+          <a:prstGeom prst="ellipse">
+            <a:avLst/>
+          </a:prstGeom>
+          <a:solidFill>
+            <a:srgbClr val="4DA3FF"/>
+          </a:solidFill>
+          <a:ln/>
+        </p:spPr>
+      </p:sp>
+      <p:sp>
+        <p:nvSpPr>
+          <p:cNvPr id="12" name="Text 10"/>
+          <p:cNvSpPr txBox="1"/>
+          <p:nvPr/>
+        </p:nvSpPr>
+        <p:spPr>
+          <a:xfrm>
+            <a:off x="1325880" y="3657600"/>
+            <a:ext cx="2651760" cy="411480"/>
+          </a:xfrm>
+          <a:prstGeom prst="rect">
+            <a:avLst/>
+          </a:prstGeom>
+          <a:noFill/>
+          <a:ln/>
+        </p:spPr>
+        <p:txBody>
+          <a:bodyPr wrap="square" lIns="0" tIns="0" rIns="0" bIns="0" rtlCol="0" anchor="ctr"/>
+          <a:lstStyle/>
+          <a:p>
+            <a:pPr indent="0" marL="0">
+              <a:buNone/>
+            </a:pPr>
+            <a:r>
+              <a:rPr lang="en-US" sz="1250" dirty="0">
+                <a:solidFill>
+                  <a:srgbClr val="E8EEF7"/>
+                </a:solidFill>
+                <a:latin typeface="Calibri" pitchFamily="34" charset="0"/>
+                <a:ea typeface="Calibri" pitchFamily="34" charset="-122"/>
+                <a:cs typeface="Calibri" pitchFamily="34" charset="-120"/>
+              </a:rPr>
+              <a:t>Per-session live missions</a:t>
+            </a:r>
+            <a:endParaRPr lang="en-US" sz="1250" dirty="0"/>
+          </a:p>
+        </p:txBody>
+      </p:sp>
+      <p:sp>
+        <p:nvSpPr>
+          <p:cNvPr id="13" name="Shape 11"/>
+          <p:cNvSpPr/>
+          <p:nvPr/>
+        </p:nvSpPr>
+        <p:spPr>
+          <a:xfrm>
+            <a:off x="1115568" y="4169664"/>
+            <a:ext cx="91440" cy="91440"/>
+          </a:xfrm>
+          <a:prstGeom prst="ellipse">
+            <a:avLst/>
+          </a:prstGeom>
+          <a:solidFill>
+            <a:srgbClr val="4DA3FF"/>
+          </a:solidFill>
+          <a:ln/>
+        </p:spPr>
+      </p:sp>
+      <p:sp>
+        <p:nvSpPr>
+          <p:cNvPr id="14" name="Text 12"/>
+          <p:cNvSpPr txBox="1"/>
+          <p:nvPr/>
+        </p:nvSpPr>
+        <p:spPr>
+          <a:xfrm>
+            <a:off x="1325880" y="4114800"/>
+            <a:ext cx="2651760" cy="411480"/>
+          </a:xfrm>
+          <a:prstGeom prst="rect">
+            <a:avLst/>
+          </a:prstGeom>
+          <a:noFill/>
+          <a:ln/>
+        </p:spPr>
+        <p:txBody>
+          <a:bodyPr wrap="square" lIns="0" tIns="0" rIns="0" bIns="0" rtlCol="0" anchor="ctr"/>
+          <a:lstStyle/>
+          <a:p>
+            <a:pPr indent="0" marL="0">
+              <a:buNone/>
+            </a:pPr>
+            <a:r>
+              <a:rPr lang="en-US" sz="1250" dirty="0">
+                <a:solidFill>
+                  <a:srgbClr val="E8EEF7"/>
+                </a:solidFill>
+                <a:latin typeface="Calibri" pitchFamily="34" charset="0"/>
+                <a:ea typeface="Calibri" pitchFamily="34" charset="-122"/>
+                <a:cs typeface="Calibri" pitchFamily="34" charset="-120"/>
+              </a:rPr>
+              <a:t>Stateless, shardable</a:t>
+            </a:r>
+            <a:endParaRPr lang="en-US" sz="1250" dirty="0"/>
+          </a:p>
+        </p:txBody>
+      </p:sp>
+      <p:sp>
+        <p:nvSpPr>
+          <p:cNvPr id="15" name="Shape 13"/>
+          <p:cNvSpPr/>
+          <p:nvPr/>
+        </p:nvSpPr>
+        <p:spPr>
+          <a:xfrm>
+            <a:off x="4389120" y="1828800"/>
+            <a:ext cx="3291840" cy="2834640"/>
           </a:xfrm>
           <a:prstGeom prst="roundRect">
             <a:avLst>
-              <a:gd name="adj" fmla="val 9000"/>
+              <a:gd name="adj" fmla="val 2903"/>
             </a:avLst>
           </a:prstGeom>
           <a:solidFill>
@@ -9186,73 +9239,95 @@
       </p:sp>
       <p:sp>
         <p:nvSpPr>
-          <p:cNvPr id="9" name="Shape 7"/>
+          <p:cNvPr id="16" name="Shape 14"/>
           <p:cNvSpPr/>
           <p:nvPr/>
         </p:nvSpPr>
         <p:spPr>
           <a:xfrm>
-            <a:off x="6428232" y="2487168"/>
-            <a:ext cx="146304" cy="146304"/>
-          </a:xfrm>
-          <a:prstGeom prst="ellipse">
-            <a:avLst/>
-          </a:prstGeom>
-          <a:solidFill>
-            <a:srgbClr val="4DA3FF"/>
-          </a:solidFill>
-          <a:ln/>
-        </p:spPr>
-      </p:sp>
-      <p:sp>
-        <p:nvSpPr>
-          <p:cNvPr id="10" name="Text 8"/>
-          <p:cNvSpPr txBox="1"/>
-          <p:nvPr/>
-        </p:nvSpPr>
-        <p:spPr>
-          <a:xfrm>
-            <a:off x="6675120" y="2221992"/>
-            <a:ext cx="4480560" cy="365760"/>
-          </a:xfrm>
-          <a:prstGeom prst="rect">
-            <a:avLst/>
-          </a:prstGeom>
-          <a:noFill/>
-          <a:ln/>
-        </p:spPr>
-        <p:txBody>
-          <a:bodyPr wrap="square" lIns="0" tIns="0" rIns="0" bIns="0" rtlCol="0" anchor="ctr"/>
-          <a:lstStyle/>
-          <a:p>
-            <a:pPr indent="0" marL="0">
-              <a:buNone/>
-            </a:pPr>
-            <a:r>
-              <a:rPr lang="en-US" sz="1500" b="1" dirty="0">
-                <a:solidFill>
-                  <a:srgbClr val="E8EEF7"/>
+            <a:off x="4663440" y="2057400"/>
+            <a:ext cx="1371600" cy="457200"/>
+          </a:xfrm>
+          <a:prstGeom prst="roundRect">
+            <a:avLst>
+              <a:gd name="adj" fmla="val 16000"/>
+            </a:avLst>
+          </a:prstGeom>
+          <a:solidFill>
+            <a:srgbClr val="33D171"/>
+          </a:solidFill>
+          <a:ln/>
+        </p:spPr>
+      </p:sp>
+      <p:sp>
+        <p:nvSpPr>
+          <p:cNvPr id="17" name="Text 15"/>
+          <p:cNvSpPr txBox="1"/>
+          <p:nvPr/>
+        </p:nvSpPr>
+        <p:spPr>
+          <a:xfrm>
+            <a:off x="4663440" y="2057400"/>
+            <a:ext cx="1371600" cy="457200"/>
+          </a:xfrm>
+          <a:prstGeom prst="rect">
+            <a:avLst/>
+          </a:prstGeom>
+          <a:noFill/>
+          <a:ln/>
+        </p:spPr>
+        <p:txBody>
+          <a:bodyPr wrap="square" lIns="0" tIns="0" rIns="0" bIns="0" rtlCol="0" anchor="ctr"/>
+          <a:lstStyle/>
+          <a:p>
+            <a:pPr algn="ctr" indent="0" marL="0">
+              <a:buNone/>
+            </a:pPr>
+            <a:r>
+              <a:rPr lang="en-US" sz="1400" b="1" dirty="0">
+                <a:solidFill>
+                  <a:srgbClr val="0B1220"/>
                 </a:solidFill>
                 <a:latin typeface="Arial" pitchFamily="34" charset="0"/>
                 <a:ea typeface="Arial" pitchFamily="34" charset="-122"/>
                 <a:cs typeface="Arial" pitchFamily="34" charset="-120"/>
               </a:rPr>
-              <a:t>Route efficiency</a:t>
-            </a:r>
-            <a:endParaRPr lang="en-US" sz="1500" dirty="0"/>
-          </a:p>
-        </p:txBody>
-      </p:sp>
-      <p:sp>
-        <p:nvSpPr>
-          <p:cNvPr id="11" name="Text 9"/>
-          <p:cNvSpPr txBox="1"/>
-          <p:nvPr/>
-        </p:nvSpPr>
-        <p:spPr>
-          <a:xfrm>
-            <a:off x="6675120" y="2578608"/>
-            <a:ext cx="4480560" cy="365760"/>
+              <a:t>Intelligence</a:t>
+            </a:r>
+            <a:endParaRPr lang="en-US" sz="1400" dirty="0"/>
+          </a:p>
+        </p:txBody>
+      </p:sp>
+      <p:sp>
+        <p:nvSpPr>
+          <p:cNvPr id="18" name="Shape 16"/>
+          <p:cNvSpPr/>
+          <p:nvPr/>
+        </p:nvSpPr>
+        <p:spPr>
+          <a:xfrm>
+            <a:off x="4681728" y="2798064"/>
+            <a:ext cx="91440" cy="91440"/>
+          </a:xfrm>
+          <a:prstGeom prst="ellipse">
+            <a:avLst/>
+          </a:prstGeom>
+          <a:solidFill>
+            <a:srgbClr val="33D171"/>
+          </a:solidFill>
+          <a:ln/>
+        </p:spPr>
+      </p:sp>
+      <p:sp>
+        <p:nvSpPr>
+          <p:cNvPr id="19" name="Text 17"/>
+          <p:cNvSpPr txBox="1"/>
+          <p:nvPr/>
+        </p:nvSpPr>
+        <p:spPr>
+          <a:xfrm>
+            <a:off x="4892040" y="2743200"/>
+            <a:ext cx="2651760" cy="411480"/>
           </a:xfrm>
           <a:prstGeom prst="rect">
             <a:avLst/>
@@ -9270,13 +9345,13 @@
             <a:r>
               <a:rPr lang="en-US" sz="1250" dirty="0">
                 <a:solidFill>
-                  <a:srgbClr val="90A4C4"/>
+                  <a:srgbClr val="E8EEF7"/>
                 </a:solidFill>
                 <a:latin typeface="Calibri" pitchFamily="34" charset="0"/>
                 <a:ea typeface="Calibri" pitchFamily="34" charset="-122"/>
                 <a:cs typeface="Calibri" pitchFamily="34" charset="-120"/>
               </a:rPr>
-              <a:t>time / fuel / risk per route; detours keep risk ~7%</a:t>
+              <a:t>PyTorch CNN nowcaster</a:t>
             </a:r>
             <a:endParaRPr lang="en-US" sz="1250" dirty="0"/>
           </a:p>
@@ -9284,18 +9359,195 @@
       </p:sp>
       <p:sp>
         <p:nvSpPr>
-          <p:cNvPr id="12" name="Shape 10"/>
+          <p:cNvPr id="20" name="Shape 18"/>
           <p:cNvSpPr/>
           <p:nvPr/>
         </p:nvSpPr>
         <p:spPr>
           <a:xfrm>
-            <a:off x="822960" y="3154680"/>
-            <a:ext cx="5074920" cy="914400"/>
+            <a:off x="4681728" y="3255264"/>
+            <a:ext cx="91440" cy="91440"/>
+          </a:xfrm>
+          <a:prstGeom prst="ellipse">
+            <a:avLst/>
+          </a:prstGeom>
+          <a:solidFill>
+            <a:srgbClr val="33D171"/>
+          </a:solidFill>
+          <a:ln/>
+        </p:spPr>
+      </p:sp>
+      <p:sp>
+        <p:nvSpPr>
+          <p:cNvPr id="21" name="Text 19"/>
+          <p:cNvSpPr txBox="1"/>
+          <p:nvPr/>
+        </p:nvSpPr>
+        <p:spPr>
+          <a:xfrm>
+            <a:off x="4892040" y="3200400"/>
+            <a:ext cx="2651760" cy="411480"/>
+          </a:xfrm>
+          <a:prstGeom prst="rect">
+            <a:avLst/>
+          </a:prstGeom>
+          <a:noFill/>
+          <a:ln/>
+        </p:spPr>
+        <p:txBody>
+          <a:bodyPr wrap="square" lIns="0" tIns="0" rIns="0" bIns="0" rtlCol="0" anchor="ctr"/>
+          <a:lstStyle/>
+          <a:p>
+            <a:pPr indent="0" marL="0">
+              <a:buNone/>
+            </a:pPr>
+            <a:r>
+              <a:rPr lang="en-US" sz="1250" dirty="0">
+                <a:solidFill>
+                  <a:srgbClr val="E8EEF7"/>
+                </a:solidFill>
+                <a:latin typeface="Calibri" pitchFamily="34" charset="0"/>
+                <a:ea typeface="Calibri" pitchFamily="34" charset="-122"/>
+                <a:cs typeface="Calibri" pitchFamily="34" charset="-120"/>
+              </a:rPr>
+              <a:t>scikit-learn GBM classifier</a:t>
+            </a:r>
+            <a:endParaRPr lang="en-US" sz="1250" dirty="0"/>
+          </a:p>
+        </p:txBody>
+      </p:sp>
+      <p:sp>
+        <p:nvSpPr>
+          <p:cNvPr id="22" name="Shape 20"/>
+          <p:cNvSpPr/>
+          <p:nvPr/>
+        </p:nvSpPr>
+        <p:spPr>
+          <a:xfrm>
+            <a:off x="4681728" y="3712464"/>
+            <a:ext cx="91440" cy="91440"/>
+          </a:xfrm>
+          <a:prstGeom prst="ellipse">
+            <a:avLst/>
+          </a:prstGeom>
+          <a:solidFill>
+            <a:srgbClr val="33D171"/>
+          </a:solidFill>
+          <a:ln/>
+        </p:spPr>
+      </p:sp>
+      <p:sp>
+        <p:nvSpPr>
+          <p:cNvPr id="23" name="Text 21"/>
+          <p:cNvSpPr txBox="1"/>
+          <p:nvPr/>
+        </p:nvSpPr>
+        <p:spPr>
+          <a:xfrm>
+            <a:off x="4892040" y="3657600"/>
+            <a:ext cx="2651760" cy="411480"/>
+          </a:xfrm>
+          <a:prstGeom prst="rect">
+            <a:avLst/>
+          </a:prstGeom>
+          <a:noFill/>
+          <a:ln/>
+        </p:spPr>
+        <p:txBody>
+          <a:bodyPr wrap="square" lIns="0" tIns="0" rIns="0" bIns="0" rtlCol="0" anchor="ctr"/>
+          <a:lstStyle/>
+          <a:p>
+            <a:pPr indent="0" marL="0">
+              <a:buNone/>
+            </a:pPr>
+            <a:r>
+              <a:rPr lang="en-US" sz="1250" dirty="0">
+                <a:solidFill>
+                  <a:srgbClr val="E8EEF7"/>
+                </a:solidFill>
+                <a:latin typeface="Calibri" pitchFamily="34" charset="0"/>
+                <a:ea typeface="Calibri" pitchFamily="34" charset="-122"/>
+                <a:cs typeface="Calibri" pitchFamily="34" charset="-120"/>
+              </a:rPr>
+              <a:t>A* + D* Lite optimizer</a:t>
+            </a:r>
+            <a:endParaRPr lang="en-US" sz="1250" dirty="0"/>
+          </a:p>
+        </p:txBody>
+      </p:sp>
+      <p:sp>
+        <p:nvSpPr>
+          <p:cNvPr id="24" name="Shape 22"/>
+          <p:cNvSpPr/>
+          <p:nvPr/>
+        </p:nvSpPr>
+        <p:spPr>
+          <a:xfrm>
+            <a:off x="4681728" y="4169664"/>
+            <a:ext cx="91440" cy="91440"/>
+          </a:xfrm>
+          <a:prstGeom prst="ellipse">
+            <a:avLst/>
+          </a:prstGeom>
+          <a:solidFill>
+            <a:srgbClr val="33D171"/>
+          </a:solidFill>
+          <a:ln/>
+        </p:spPr>
+      </p:sp>
+      <p:sp>
+        <p:nvSpPr>
+          <p:cNvPr id="25" name="Text 23"/>
+          <p:cNvSpPr txBox="1"/>
+          <p:nvPr/>
+        </p:nvSpPr>
+        <p:spPr>
+          <a:xfrm>
+            <a:off x="4892040" y="4114800"/>
+            <a:ext cx="2651760" cy="411480"/>
+          </a:xfrm>
+          <a:prstGeom prst="rect">
+            <a:avLst/>
+          </a:prstGeom>
+          <a:noFill/>
+          <a:ln/>
+        </p:spPr>
+        <p:txBody>
+          <a:bodyPr wrap="square" lIns="0" tIns="0" rIns="0" bIns="0" rtlCol="0" anchor="ctr"/>
+          <a:lstStyle/>
+          <a:p>
+            <a:pPr indent="0" marL="0">
+              <a:buNone/>
+            </a:pPr>
+            <a:r>
+              <a:rPr lang="en-US" sz="1250" dirty="0">
+                <a:solidFill>
+                  <a:srgbClr val="E8EEF7"/>
+                </a:solidFill>
+                <a:latin typeface="Calibri" pitchFamily="34" charset="0"/>
+                <a:ea typeface="Calibri" pitchFamily="34" charset="-122"/>
+                <a:cs typeface="Calibri" pitchFamily="34" charset="-120"/>
+              </a:rPr>
+              <a:t>Multi-objective weighting</a:t>
+            </a:r>
+            <a:endParaRPr lang="en-US" sz="1250" dirty="0"/>
+          </a:p>
+        </p:txBody>
+      </p:sp>
+      <p:sp>
+        <p:nvSpPr>
+          <p:cNvPr id="26" name="Shape 24"/>
+          <p:cNvSpPr/>
+          <p:nvPr/>
+        </p:nvSpPr>
+        <p:spPr>
+          <a:xfrm>
+            <a:off x="7955280" y="1828800"/>
+            <a:ext cx="3291840" cy="2834640"/>
           </a:xfrm>
           <a:prstGeom prst="roundRect">
             <a:avLst>
-              <a:gd name="adj" fmla="val 9000"/>
+              <a:gd name="adj" fmla="val 2903"/>
             </a:avLst>
           </a:prstGeom>
           <a:solidFill>
@@ -9318,17 +9570,19 @@
       </p:sp>
       <p:sp>
         <p:nvSpPr>
-          <p:cNvPr id="13" name="Shape 11"/>
+          <p:cNvPr id="27" name="Shape 25"/>
           <p:cNvSpPr/>
           <p:nvPr/>
         </p:nvSpPr>
         <p:spPr>
           <a:xfrm>
-            <a:off x="1078992" y="3538728"/>
-            <a:ext cx="146304" cy="146304"/>
-          </a:xfrm>
-          <a:prstGeom prst="ellipse">
-            <a:avLst/>
+            <a:off x="8229600" y="2057400"/>
+            <a:ext cx="1371600" cy="457200"/>
+          </a:xfrm>
+          <a:prstGeom prst="roundRect">
+            <a:avLst>
+              <a:gd name="adj" fmla="val 16000"/>
+            </a:avLst>
           </a:prstGeom>
           <a:solidFill>
             <a:srgbClr val="F5B942"/>
@@ -9338,53 +9592,73 @@
       </p:sp>
       <p:sp>
         <p:nvSpPr>
-          <p:cNvPr id="14" name="Text 12"/>
-          <p:cNvSpPr txBox="1"/>
-          <p:nvPr/>
-        </p:nvSpPr>
-        <p:spPr>
-          <a:xfrm>
-            <a:off x="1325880" y="3273552"/>
-            <a:ext cx="4480560" cy="365760"/>
-          </a:xfrm>
-          <a:prstGeom prst="rect">
-            <a:avLst/>
-          </a:prstGeom>
-          <a:noFill/>
-          <a:ln/>
-        </p:spPr>
-        <p:txBody>
-          <a:bodyPr wrap="square" lIns="0" tIns="0" rIns="0" bIns="0" rtlCol="0" anchor="ctr"/>
-          <a:lstStyle/>
-          <a:p>
-            <a:pPr indent="0" marL="0">
-              <a:buNone/>
-            </a:pPr>
-            <a:r>
-              <a:rPr lang="en-US" sz="1500" b="1" dirty="0">
-                <a:solidFill>
-                  <a:srgbClr val="E8EEF7"/>
+          <p:cNvPr id="28" name="Text 26"/>
+          <p:cNvSpPr txBox="1"/>
+          <p:nvPr/>
+        </p:nvSpPr>
+        <p:spPr>
+          <a:xfrm>
+            <a:off x="8229600" y="2057400"/>
+            <a:ext cx="1371600" cy="457200"/>
+          </a:xfrm>
+          <a:prstGeom prst="rect">
+            <a:avLst/>
+          </a:prstGeom>
+          <a:noFill/>
+          <a:ln/>
+        </p:spPr>
+        <p:txBody>
+          <a:bodyPr wrap="square" lIns="0" tIns="0" rIns="0" bIns="0" rtlCol="0" anchor="ctr"/>
+          <a:lstStyle/>
+          <a:p>
+            <a:pPr algn="ctr" indent="0" marL="0">
+              <a:buNone/>
+            </a:pPr>
+            <a:r>
+              <a:rPr lang="en-US" sz="1400" b="1" dirty="0">
+                <a:solidFill>
+                  <a:srgbClr val="0B1220"/>
                 </a:solidFill>
                 <a:latin typeface="Arial" pitchFamily="34" charset="0"/>
                 <a:ea typeface="Arial" pitchFamily="34" charset="-122"/>
                 <a:cs typeface="Arial" pitchFamily="34" charset="-120"/>
               </a:rPr>
-              <a:t>Innovation</a:t>
-            </a:r>
-            <a:endParaRPr lang="en-US" sz="1500" dirty="0"/>
-          </a:p>
-        </p:txBody>
-      </p:sp>
-      <p:sp>
-        <p:nvSpPr>
-          <p:cNvPr id="15" name="Text 13"/>
-          <p:cNvSpPr txBox="1"/>
-          <p:nvPr/>
-        </p:nvSpPr>
-        <p:spPr>
-          <a:xfrm>
-            <a:off x="1325880" y="3630168"/>
-            <a:ext cx="4480560" cy="365760"/>
+              <a:t>Frontend</a:t>
+            </a:r>
+            <a:endParaRPr lang="en-US" sz="1400" dirty="0"/>
+          </a:p>
+        </p:txBody>
+      </p:sp>
+      <p:sp>
+        <p:nvSpPr>
+          <p:cNvPr id="29" name="Shape 27"/>
+          <p:cNvSpPr/>
+          <p:nvPr/>
+        </p:nvSpPr>
+        <p:spPr>
+          <a:xfrm>
+            <a:off x="8247888" y="2798064"/>
+            <a:ext cx="91440" cy="91440"/>
+          </a:xfrm>
+          <a:prstGeom prst="ellipse">
+            <a:avLst/>
+          </a:prstGeom>
+          <a:solidFill>
+            <a:srgbClr val="F5B942"/>
+          </a:solidFill>
+          <a:ln/>
+        </p:spPr>
+      </p:sp>
+      <p:sp>
+        <p:nvSpPr>
+          <p:cNvPr id="30" name="Text 28"/>
+          <p:cNvSpPr txBox="1"/>
+          <p:nvPr/>
+        </p:nvSpPr>
+        <p:spPr>
+          <a:xfrm>
+            <a:off x="8458200" y="2743200"/>
+            <a:ext cx="2651760" cy="411480"/>
           </a:xfrm>
           <a:prstGeom prst="rect">
             <a:avLst/>
@@ -9402,13 +9676,13 @@
             <a:r>
               <a:rPr lang="en-US" sz="1250" dirty="0">
                 <a:solidFill>
-                  <a:srgbClr val="90A4C4"/>
+                  <a:srgbClr val="E8EEF7"/>
                 </a:solidFill>
                 <a:latin typeface="Calibri" pitchFamily="34" charset="0"/>
                 <a:ea typeface="Calibri" pitchFamily="34" charset="-122"/>
                 <a:cs typeface="Calibri" pitchFamily="34" charset="-120"/>
               </a:rPr>
-              <a:t>adaptive D* Lite + ML pre-emptive avoidance · 10.9×</a:t>
+              <a:t>Leaflet operator dashboard</a:t>
             </a:r>
             <a:endParaRPr lang="en-US" sz="1250" dirty="0"/>
           </a:p>
@@ -9416,22 +9690,199 @@
       </p:sp>
       <p:sp>
         <p:nvSpPr>
-          <p:cNvPr id="16" name="Shape 14"/>
+          <p:cNvPr id="31" name="Shape 29"/>
           <p:cNvSpPr/>
           <p:nvPr/>
         </p:nvSpPr>
         <p:spPr>
           <a:xfrm>
-            <a:off x="6172200" y="3154680"/>
-            <a:ext cx="5074920" cy="914400"/>
+            <a:off x="8247888" y="3255264"/>
+            <a:ext cx="91440" cy="91440"/>
+          </a:xfrm>
+          <a:prstGeom prst="ellipse">
+            <a:avLst/>
+          </a:prstGeom>
+          <a:solidFill>
+            <a:srgbClr val="F5B942"/>
+          </a:solidFill>
+          <a:ln/>
+        </p:spPr>
+      </p:sp>
+      <p:sp>
+        <p:nvSpPr>
+          <p:cNvPr id="32" name="Text 30"/>
+          <p:cNvSpPr txBox="1"/>
+          <p:nvPr/>
+        </p:nvSpPr>
+        <p:spPr>
+          <a:xfrm>
+            <a:off x="8458200" y="3200400"/>
+            <a:ext cx="2651760" cy="411480"/>
+          </a:xfrm>
+          <a:prstGeom prst="rect">
+            <a:avLst/>
+          </a:prstGeom>
+          <a:noFill/>
+          <a:ln/>
+        </p:spPr>
+        <p:txBody>
+          <a:bodyPr wrap="square" lIns="0" tIns="0" rIns="0" bIns="0" rtlCol="0" anchor="ctr"/>
+          <a:lstStyle/>
+          <a:p>
+            <a:pPr indent="0" marL="0">
+              <a:buNone/>
+            </a:pPr>
+            <a:r>
+              <a:rPr lang="en-US" sz="1250" dirty="0">
+                <a:solidFill>
+                  <a:srgbClr val="E8EEF7"/>
+                </a:solidFill>
+                <a:latin typeface="Calibri" pitchFamily="34" charset="0"/>
+                <a:ea typeface="Calibri" pitchFamily="34" charset="-122"/>
+                <a:cs typeface="Calibri" pitchFamily="34" charset="-120"/>
+              </a:rPr>
+              <a:t>Danger heatmap + threat rings</a:t>
+            </a:r>
+            <a:endParaRPr lang="en-US" sz="1250" dirty="0"/>
+          </a:p>
+        </p:txBody>
+      </p:sp>
+      <p:sp>
+        <p:nvSpPr>
+          <p:cNvPr id="33" name="Shape 31"/>
+          <p:cNvSpPr/>
+          <p:nvPr/>
+        </p:nvSpPr>
+        <p:spPr>
+          <a:xfrm>
+            <a:off x="8247888" y="3712464"/>
+            <a:ext cx="91440" cy="91440"/>
+          </a:xfrm>
+          <a:prstGeom prst="ellipse">
+            <a:avLst/>
+          </a:prstGeom>
+          <a:solidFill>
+            <a:srgbClr val="F5B942"/>
+          </a:solidFill>
+          <a:ln/>
+        </p:spPr>
+      </p:sp>
+      <p:sp>
+        <p:nvSpPr>
+          <p:cNvPr id="34" name="Text 32"/>
+          <p:cNvSpPr txBox="1"/>
+          <p:nvPr/>
+        </p:nvSpPr>
+        <p:spPr>
+          <a:xfrm>
+            <a:off x="8458200" y="3657600"/>
+            <a:ext cx="2651760" cy="411480"/>
+          </a:xfrm>
+          <a:prstGeom prst="rect">
+            <a:avLst/>
+          </a:prstGeom>
+          <a:noFill/>
+          <a:ln/>
+        </p:spPr>
+        <p:txBody>
+          <a:bodyPr wrap="square" lIns="0" tIns="0" rIns="0" bIns="0" rtlCol="0" anchor="ctr"/>
+          <a:lstStyle/>
+          <a:p>
+            <a:pPr indent="0" marL="0">
+              <a:buNone/>
+            </a:pPr>
+            <a:r>
+              <a:rPr lang="en-US" sz="1250" dirty="0">
+                <a:solidFill>
+                  <a:srgbClr val="E8EEF7"/>
+                </a:solidFill>
+                <a:latin typeface="Calibri" pitchFamily="34" charset="0"/>
+                <a:ea typeface="Calibri" pitchFamily="34" charset="-122"/>
+                <a:cs typeface="Calibri" pitchFamily="34" charset="-120"/>
+              </a:rPr>
+              <a:t>Priority sliders, live clock</a:t>
+            </a:r>
+            <a:endParaRPr lang="en-US" sz="1250" dirty="0"/>
+          </a:p>
+        </p:txBody>
+      </p:sp>
+      <p:sp>
+        <p:nvSpPr>
+          <p:cNvPr id="35" name="Shape 33"/>
+          <p:cNvSpPr/>
+          <p:nvPr/>
+        </p:nvSpPr>
+        <p:spPr>
+          <a:xfrm>
+            <a:off x="8247888" y="4169664"/>
+            <a:ext cx="91440" cy="91440"/>
+          </a:xfrm>
+          <a:prstGeom prst="ellipse">
+            <a:avLst/>
+          </a:prstGeom>
+          <a:solidFill>
+            <a:srgbClr val="F5B942"/>
+          </a:solidFill>
+          <a:ln/>
+        </p:spPr>
+      </p:sp>
+      <p:sp>
+        <p:nvSpPr>
+          <p:cNvPr id="36" name="Text 34"/>
+          <p:cNvSpPr txBox="1"/>
+          <p:nvPr/>
+        </p:nvSpPr>
+        <p:spPr>
+          <a:xfrm>
+            <a:off x="8458200" y="4114800"/>
+            <a:ext cx="2651760" cy="411480"/>
+          </a:xfrm>
+          <a:prstGeom prst="rect">
+            <a:avLst/>
+          </a:prstGeom>
+          <a:noFill/>
+          <a:ln/>
+        </p:spPr>
+        <p:txBody>
+          <a:bodyPr wrap="square" lIns="0" tIns="0" rIns="0" bIns="0" rtlCol="0" anchor="ctr"/>
+          <a:lstStyle/>
+          <a:p>
+            <a:pPr indent="0" marL="0">
+              <a:buNone/>
+            </a:pPr>
+            <a:r>
+              <a:rPr lang="en-US" sz="1250" dirty="0">
+                <a:solidFill>
+                  <a:srgbClr val="E8EEF7"/>
+                </a:solidFill>
+                <a:latin typeface="Calibri" pitchFamily="34" charset="0"/>
+                <a:ea typeface="Calibri" pitchFamily="34" charset="-122"/>
+                <a:cs typeface="Calibri" pitchFamily="34" charset="-120"/>
+              </a:rPr>
+              <a:t>Zero-build, one command</a:t>
+            </a:r>
+            <a:endParaRPr lang="en-US" sz="1250" dirty="0"/>
+          </a:p>
+        </p:txBody>
+      </p:sp>
+      <p:sp>
+        <p:nvSpPr>
+          <p:cNvPr id="37" name="Shape 35"/>
+          <p:cNvSpPr/>
+          <p:nvPr/>
+        </p:nvSpPr>
+        <p:spPr>
+          <a:xfrm>
+            <a:off x="822960" y="4892040"/>
+            <a:ext cx="10515600" cy="1371600"/>
           </a:xfrm>
           <a:prstGeom prst="roundRect">
             <a:avLst>
-              <a:gd name="adj" fmla="val 9000"/>
+              <a:gd name="adj" fmla="val 6000"/>
             </a:avLst>
           </a:prstGeom>
           <a:solidFill>
-            <a:srgbClr val="16223A"/>
+            <a:srgbClr val="1E2C49"/>
           </a:solidFill>
           <a:ln w="12700">
             <a:solidFill>
@@ -9450,89 +9901,108 @@
       </p:sp>
       <p:sp>
         <p:nvSpPr>
-          <p:cNvPr id="17" name="Shape 15"/>
-          <p:cNvSpPr/>
-          <p:nvPr/>
-        </p:nvSpPr>
-        <p:spPr>
-          <a:xfrm>
-            <a:off x="6428232" y="3538728"/>
-            <a:ext cx="146304" cy="146304"/>
-          </a:xfrm>
-          <a:prstGeom prst="ellipse">
-            <a:avLst/>
-          </a:prstGeom>
-          <a:solidFill>
-            <a:srgbClr val="4DA3FF"/>
-          </a:solidFill>
-          <a:ln/>
-        </p:spPr>
-      </p:sp>
-      <p:sp>
-        <p:nvSpPr>
-          <p:cNvPr id="18" name="Text 16"/>
-          <p:cNvSpPr txBox="1"/>
-          <p:nvPr/>
-        </p:nvSpPr>
-        <p:spPr>
-          <a:xfrm>
-            <a:off x="6675120" y="3273552"/>
-            <a:ext cx="4480560" cy="365760"/>
-          </a:xfrm>
-          <a:prstGeom prst="rect">
-            <a:avLst/>
-          </a:prstGeom>
-          <a:noFill/>
-          <a:ln/>
-        </p:spPr>
-        <p:txBody>
-          <a:bodyPr wrap="square" lIns="0" tIns="0" rIns="0" bIns="0" rtlCol="0" anchor="ctr"/>
-          <a:lstStyle/>
-          <a:p>
-            <a:pPr indent="0" marL="0">
-              <a:buNone/>
-            </a:pPr>
-            <a:r>
-              <a:rPr lang="en-US" sz="1500" b="1" dirty="0">
-                <a:solidFill>
-                  <a:srgbClr val="E8EEF7"/>
+          <p:cNvPr id="38" name="Text 36"/>
+          <p:cNvSpPr txBox="1"/>
+          <p:nvPr/>
+        </p:nvSpPr>
+        <p:spPr>
+          <a:xfrm>
+            <a:off x="1097280" y="5074920"/>
+            <a:ext cx="3657600" cy="320040"/>
+          </a:xfrm>
+          <a:prstGeom prst="rect">
+            <a:avLst/>
+          </a:prstGeom>
+          <a:noFill/>
+          <a:ln/>
+        </p:spPr>
+        <p:txBody>
+          <a:bodyPr wrap="square" lIns="0" tIns="0" rIns="0" bIns="0" rtlCol="0" anchor="ctr"/>
+          <a:lstStyle/>
+          <a:p>
+            <a:pPr indent="0" marL="0">
+              <a:buNone/>
+            </a:pPr>
+            <a:r>
+              <a:rPr lang="en-US" sz="1400" b="1" dirty="0">
+                <a:solidFill>
+                  <a:srgbClr val="FF5D5D"/>
                 </a:solidFill>
                 <a:latin typeface="Arial" pitchFamily="34" charset="0"/>
                 <a:ea typeface="Arial" pitchFamily="34" charset="-122"/>
                 <a:cs typeface="Arial" pitchFamily="34" charset="-120"/>
               </a:rPr>
-              <a:t>User interface</a:t>
-            </a:r>
-            <a:endParaRPr lang="en-US" sz="1500" dirty="0"/>
-          </a:p>
-        </p:txBody>
-      </p:sp>
-      <p:sp>
-        <p:nvSpPr>
-          <p:cNvPr id="19" name="Text 17"/>
-          <p:cNvSpPr txBox="1"/>
-          <p:nvPr/>
-        </p:nvSpPr>
-        <p:spPr>
-          <a:xfrm>
-            <a:off x="6675120" y="3630168"/>
-            <a:ext cx="4480560" cy="365760"/>
-          </a:xfrm>
-          <a:prstGeom prst="rect">
-            <a:avLst/>
-          </a:prstGeom>
-          <a:noFill/>
-          <a:ln/>
-        </p:spPr>
-        <p:txBody>
-          <a:bodyPr wrap="square" lIns="0" tIns="0" rIns="0" bIns="0" rtlCol="0" anchor="ctr"/>
-          <a:lstStyle/>
-          <a:p>
-            <a:pPr indent="0" marL="0">
-              <a:buNone/>
-            </a:pPr>
-            <a:r>
-              <a:rPr lang="en-US" sz="1250" dirty="0">
+              <a:t>Security (brief §7)</a:t>
+            </a:r>
+            <a:endParaRPr lang="en-US" sz="1400" dirty="0"/>
+          </a:p>
+        </p:txBody>
+      </p:sp>
+      <p:sp>
+        <p:nvSpPr>
+          <p:cNvPr id="39" name="Text 37"/>
+          <p:cNvSpPr txBox="1"/>
+          <p:nvPr/>
+        </p:nvSpPr>
+        <p:spPr>
+          <a:xfrm>
+            <a:off x="1097280" y="5440680"/>
+            <a:ext cx="3291840" cy="320040"/>
+          </a:xfrm>
+          <a:prstGeom prst="rect">
+            <a:avLst/>
+          </a:prstGeom>
+          <a:noFill/>
+          <a:ln/>
+        </p:spPr>
+        <p:txBody>
+          <a:bodyPr wrap="square" lIns="0" tIns="0" rIns="0" bIns="0" rtlCol="0" anchor="ctr"/>
+          <a:lstStyle/>
+          <a:p>
+            <a:pPr indent="0" marL="0">
+              <a:buNone/>
+            </a:pPr>
+            <a:r>
+              <a:rPr lang="en-US" sz="1400" b="1" dirty="0">
+                <a:solidFill>
+                  <a:srgbClr val="E8EEF7"/>
+                </a:solidFill>
+                <a:latin typeface="Arial" pitchFamily="34" charset="0"/>
+                <a:ea typeface="Arial" pitchFamily="34" charset="-122"/>
+                <a:cs typeface="Arial" pitchFamily="34" charset="-120"/>
+              </a:rPr>
+              <a:t>JWT auth</a:t>
+            </a:r>
+            <a:endParaRPr lang="en-US" sz="1400" dirty="0"/>
+          </a:p>
+        </p:txBody>
+      </p:sp>
+      <p:sp>
+        <p:nvSpPr>
+          <p:cNvPr id="40" name="Text 38"/>
+          <p:cNvSpPr txBox="1"/>
+          <p:nvPr/>
+        </p:nvSpPr>
+        <p:spPr>
+          <a:xfrm>
+            <a:off x="1097280" y="5760720"/>
+            <a:ext cx="3291840" cy="411480"/>
+          </a:xfrm>
+          <a:prstGeom prst="rect">
+            <a:avLst/>
+          </a:prstGeom>
+          <a:noFill/>
+          <a:ln/>
+        </p:spPr>
+        <p:txBody>
+          <a:bodyPr wrap="square" lIns="0" tIns="0" rIns="0" bIns="0" rtlCol="0" anchor="ctr"/>
+          <a:lstStyle/>
+          <a:p>
+            <a:pPr indent="0" marL="0">
+              <a:buNone/>
+            </a:pPr>
+            <a:r>
+              <a:rPr lang="en-US" sz="1200" dirty="0">
                 <a:solidFill>
                   <a:srgbClr val="90A4C4"/>
                 </a:solidFill>
@@ -9540,21 +10010,287 @@
                 <a:ea typeface="Calibri" pitchFamily="34" charset="-122"/>
                 <a:cs typeface="Calibri" pitchFamily="34" charset="-120"/>
               </a:rPr>
-              <a:t>live command-center dashboard, one command</a:t>
-            </a:r>
-            <a:endParaRPr lang="en-US" sz="1250" dirty="0"/>
-          </a:p>
-        </p:txBody>
-      </p:sp>
-      <p:sp>
-        <p:nvSpPr>
-          <p:cNvPr id="20" name="Shape 18"/>
+              <a:t>hashed operator credential (PBKDF2)</a:t>
+            </a:r>
+            <a:endParaRPr lang="en-US" sz="1200" dirty="0"/>
+          </a:p>
+        </p:txBody>
+      </p:sp>
+      <p:sp>
+        <p:nvSpPr>
+          <p:cNvPr id="41" name="Text 39"/>
+          <p:cNvSpPr txBox="1"/>
+          <p:nvPr/>
+        </p:nvSpPr>
+        <p:spPr>
+          <a:xfrm>
+            <a:off x="4526280" y="5440680"/>
+            <a:ext cx="3291840" cy="320040"/>
+          </a:xfrm>
+          <a:prstGeom prst="rect">
+            <a:avLst/>
+          </a:prstGeom>
+          <a:noFill/>
+          <a:ln/>
+        </p:spPr>
+        <p:txBody>
+          <a:bodyPr wrap="square" lIns="0" tIns="0" rIns="0" bIns="0" rtlCol="0" anchor="ctr"/>
+          <a:lstStyle/>
+          <a:p>
+            <a:pPr indent="0" marL="0">
+              <a:buNone/>
+            </a:pPr>
+            <a:r>
+              <a:rPr lang="en-US" sz="1400" b="1" dirty="0">
+                <a:solidFill>
+                  <a:srgbClr val="E8EEF7"/>
+                </a:solidFill>
+                <a:latin typeface="Arial" pitchFamily="34" charset="0"/>
+                <a:ea typeface="Arial" pitchFamily="34" charset="-122"/>
+                <a:cs typeface="Arial" pitchFamily="34" charset="-120"/>
+              </a:rPr>
+              <a:t>AES / Fernet</a:t>
+            </a:r>
+            <a:endParaRPr lang="en-US" sz="1400" dirty="0"/>
+          </a:p>
+        </p:txBody>
+      </p:sp>
+      <p:sp>
+        <p:nvSpPr>
+          <p:cNvPr id="42" name="Text 40"/>
+          <p:cNvSpPr txBox="1"/>
+          <p:nvPr/>
+        </p:nvSpPr>
+        <p:spPr>
+          <a:xfrm>
+            <a:off x="4526280" y="5760720"/>
+            <a:ext cx="3291840" cy="411480"/>
+          </a:xfrm>
+          <a:prstGeom prst="rect">
+            <a:avLst/>
+          </a:prstGeom>
+          <a:noFill/>
+          <a:ln/>
+        </p:spPr>
+        <p:txBody>
+          <a:bodyPr wrap="square" lIns="0" tIns="0" rIns="0" bIns="0" rtlCol="0" anchor="ctr"/>
+          <a:lstStyle/>
+          <a:p>
+            <a:pPr indent="0" marL="0">
+              <a:buNone/>
+            </a:pPr>
+            <a:r>
+              <a:rPr lang="en-US" sz="1200" dirty="0">
+                <a:solidFill>
+                  <a:srgbClr val="90A4C4"/>
+                </a:solidFill>
+                <a:latin typeface="Calibri" pitchFamily="34" charset="0"/>
+                <a:ea typeface="Calibri" pitchFamily="34" charset="-122"/>
+                <a:cs typeface="Calibri" pitchFamily="34" charset="-120"/>
+              </a:rPr>
+              <a:t>encryption of stored scenarios</a:t>
+            </a:r>
+            <a:endParaRPr lang="en-US" sz="1200" dirty="0"/>
+          </a:p>
+        </p:txBody>
+      </p:sp>
+      <p:sp>
+        <p:nvSpPr>
+          <p:cNvPr id="43" name="Text 41"/>
+          <p:cNvSpPr txBox="1"/>
+          <p:nvPr/>
+        </p:nvSpPr>
+        <p:spPr>
+          <a:xfrm>
+            <a:off x="7955280" y="5440680"/>
+            <a:ext cx="3291840" cy="320040"/>
+          </a:xfrm>
+          <a:prstGeom prst="rect">
+            <a:avLst/>
+          </a:prstGeom>
+          <a:noFill/>
+          <a:ln/>
+        </p:spPr>
+        <p:txBody>
+          <a:bodyPr wrap="square" lIns="0" tIns="0" rIns="0" bIns="0" rtlCol="0" anchor="ctr"/>
+          <a:lstStyle/>
+          <a:p>
+            <a:pPr indent="0" marL="0">
+              <a:buNone/>
+            </a:pPr>
+            <a:r>
+              <a:rPr lang="en-US" sz="1400" b="1" dirty="0">
+                <a:solidFill>
+                  <a:srgbClr val="E8EEF7"/>
+                </a:solidFill>
+                <a:latin typeface="Arial" pitchFamily="34" charset="0"/>
+                <a:ea typeface="Arial" pitchFamily="34" charset="-122"/>
+                <a:cs typeface="Arial" pitchFamily="34" charset="-120"/>
+              </a:rPr>
+              <a:t>Env-var secrets</a:t>
+            </a:r>
+            <a:endParaRPr lang="en-US" sz="1400" dirty="0"/>
+          </a:p>
+        </p:txBody>
+      </p:sp>
+      <p:sp>
+        <p:nvSpPr>
+          <p:cNvPr id="44" name="Text 42"/>
+          <p:cNvSpPr txBox="1"/>
+          <p:nvPr/>
+        </p:nvSpPr>
+        <p:spPr>
+          <a:xfrm>
+            <a:off x="7955280" y="5760720"/>
+            <a:ext cx="3291840" cy="411480"/>
+          </a:xfrm>
+          <a:prstGeom prst="rect">
+            <a:avLst/>
+          </a:prstGeom>
+          <a:noFill/>
+          <a:ln/>
+        </p:spPr>
+        <p:txBody>
+          <a:bodyPr wrap="square" lIns="0" tIns="0" rIns="0" bIns="0" rtlCol="0" anchor="ctr"/>
+          <a:lstStyle/>
+          <a:p>
+            <a:pPr indent="0" marL="0">
+              <a:buNone/>
+            </a:pPr>
+            <a:r>
+              <a:rPr lang="en-US" sz="1200" dirty="0">
+                <a:solidFill>
+                  <a:srgbClr val="90A4C4"/>
+                </a:solidFill>
+                <a:latin typeface="Calibri" pitchFamily="34" charset="0"/>
+                <a:ea typeface="Calibri" pitchFamily="34" charset="-122"/>
+                <a:cs typeface="Calibri" pitchFamily="34" charset="-120"/>
+              </a:rPr>
+              <a:t>no plaintext keys in code</a:t>
+            </a:r>
+            <a:endParaRPr lang="en-US" sz="1200" dirty="0"/>
+          </a:p>
+        </p:txBody>
+      </p:sp>
+    </p:spTree>
+  </p:cSld>
+  <p:clrMapOvr>
+    <a:masterClrMapping/>
+  </p:clrMapOvr>
+</p:sld>
+</file>
+
+<file path=ppt/slides/slide9.xml><?xml version="1.0" encoding="utf-8"?>
+<p:sld xmlns:a="http://schemas.openxmlformats.org/drawingml/2006/main" xmlns:r="http://schemas.openxmlformats.org/officeDocument/2006/relationships" xmlns:p="http://schemas.openxmlformats.org/presentationml/2006/main">
+  <p:cSld name="Slide 9">
+    <p:bg>
+      <p:bgPr>
+        <a:solidFill>
+          <a:srgbClr val="0B1220"/>
+        </a:solidFill>
+      </p:bgPr>
+    </p:bg>
+    <p:spTree>
+      <p:nvGrpSpPr>
+        <p:cNvPr id="1" name=""/>
+        <p:cNvGrpSpPr/>
+        <p:nvPr/>
+      </p:nvGrpSpPr>
+      <p:grpSpPr>
+        <a:xfrm>
+          <a:off x="0" y="0"/>
+          <a:ext cx="0" cy="0"/>
+          <a:chOff x="0" y="0"/>
+          <a:chExt cx="0" cy="0"/>
+        </a:xfrm>
+      </p:grpSpPr>
+      <p:sp>
+        <p:nvSpPr>
+          <p:cNvPr id="2" name="Text 0"/>
+          <p:cNvSpPr txBox="1"/>
+          <p:nvPr/>
+        </p:nvSpPr>
+        <p:spPr>
+          <a:xfrm>
+            <a:off x="822960" y="640080"/>
+            <a:ext cx="5486400" cy="274320"/>
+          </a:xfrm>
+          <a:prstGeom prst="rect">
+            <a:avLst/>
+          </a:prstGeom>
+          <a:noFill/>
+          <a:ln/>
+        </p:spPr>
+        <p:txBody>
+          <a:bodyPr wrap="square" lIns="0" tIns="0" rIns="0" bIns="0" rtlCol="0" anchor="ctr"/>
+          <a:lstStyle/>
+          <a:p>
+            <a:pPr indent="0" marL="0">
+              <a:buNone/>
+            </a:pPr>
+            <a:r>
+              <a:rPr lang="en-US" sz="1200" b="1" spc="300" kern="0" dirty="0">
+                <a:solidFill>
+                  <a:srgbClr val="4DA3FF"/>
+                </a:solidFill>
+                <a:latin typeface="Arial" pitchFamily="34" charset="0"/>
+                <a:ea typeface="Arial" pitchFamily="34" charset="-122"/>
+                <a:cs typeface="Arial" pitchFamily="34" charset="-120"/>
+              </a:rPr>
+              <a:t>RESULTS · MAPPED TO JUDGING CRITERIA</a:t>
+            </a:r>
+            <a:endParaRPr lang="en-US" sz="1200" dirty="0"/>
+          </a:p>
+        </p:txBody>
+      </p:sp>
+      <p:sp>
+        <p:nvSpPr>
+          <p:cNvPr id="3" name="Text 1"/>
+          <p:cNvSpPr txBox="1"/>
+          <p:nvPr/>
+        </p:nvSpPr>
+        <p:spPr>
+          <a:xfrm>
+            <a:off x="777240" y="1005840"/>
+            <a:ext cx="10789920" cy="822960"/>
+          </a:xfrm>
+          <a:prstGeom prst="rect">
+            <a:avLst/>
+          </a:prstGeom>
+          <a:noFill/>
+          <a:ln/>
+        </p:spPr>
+        <p:txBody>
+          <a:bodyPr wrap="square" lIns="0" tIns="0" rIns="0" bIns="0" rtlCol="0" anchor="ctr"/>
+          <a:lstStyle/>
+          <a:p>
+            <a:pPr indent="0" marL="0">
+              <a:buNone/>
+            </a:pPr>
+            <a:r>
+              <a:rPr lang="en-US" sz="4000" b="1" dirty="0">
+                <a:solidFill>
+                  <a:srgbClr val="E8EEF7"/>
+                </a:solidFill>
+                <a:latin typeface="Arial" pitchFamily="34" charset="0"/>
+                <a:ea typeface="Arial" pitchFamily="34" charset="-122"/>
+                <a:cs typeface="Arial" pitchFamily="34" charset="-120"/>
+              </a:rPr>
+              <a:t>A complete, working prototype</a:t>
+            </a:r>
+            <a:endParaRPr lang="en-US" sz="4000" dirty="0"/>
+          </a:p>
+        </p:txBody>
+      </p:sp>
+      <p:sp>
+        <p:nvSpPr>
+          <p:cNvPr id="4" name="Shape 2"/>
           <p:cNvSpPr/>
           <p:nvPr/>
         </p:nvSpPr>
         <p:spPr>
           <a:xfrm>
-            <a:off x="822960" y="4206240"/>
+            <a:off x="822960" y="2103120"/>
             <a:ext cx="5074920" cy="914400"/>
           </a:xfrm>
           <a:prstGeom prst="roundRect">
@@ -9582,13 +10318,13 @@
       </p:sp>
       <p:sp>
         <p:nvSpPr>
-          <p:cNvPr id="21" name="Shape 19"/>
+          <p:cNvPr id="5" name="Shape 3"/>
           <p:cNvSpPr/>
           <p:nvPr/>
         </p:nvSpPr>
         <p:spPr>
           <a:xfrm>
-            <a:off x="1078992" y="4590288"/>
+            <a:off x="1078992" y="2487168"/>
             <a:ext cx="146304" cy="146304"/>
           </a:xfrm>
           <a:prstGeom prst="ellipse">
@@ -9602,13 +10338,13 @@
       </p:sp>
       <p:sp>
         <p:nvSpPr>
-          <p:cNvPr id="22" name="Text 20"/>
-          <p:cNvSpPr txBox="1"/>
-          <p:nvPr/>
-        </p:nvSpPr>
-        <p:spPr>
-          <a:xfrm>
-            <a:off x="1325880" y="4325112"/>
+          <p:cNvPr id="6" name="Text 4"/>
+          <p:cNvSpPr txBox="1"/>
+          <p:nvPr/>
+        </p:nvSpPr>
+        <p:spPr>
+          <a:xfrm>
+            <a:off x="1325880" y="2221992"/>
             <a:ext cx="4480560" cy="365760"/>
           </a:xfrm>
           <a:prstGeom prst="rect">
@@ -9633,7 +10369,7 @@
                 <a:ea typeface="Arial" pitchFamily="34" charset="-122"/>
                 <a:cs typeface="Arial" pitchFamily="34" charset="-120"/>
               </a:rPr>
-              <a:t>Documentation</a:t>
+              <a:t>Prediction accuracy</a:t>
             </a:r>
             <a:endParaRPr lang="en-US" sz="1500" dirty="0"/>
           </a:p>
@@ -9641,13 +10377,13 @@
       </p:sp>
       <p:sp>
         <p:nvSpPr>
-          <p:cNvPr id="23" name="Text 21"/>
-          <p:cNvSpPr txBox="1"/>
-          <p:nvPr/>
-        </p:nvSpPr>
-        <p:spPr>
-          <a:xfrm>
-            <a:off x="1325880" y="4681728"/>
+          <p:cNvPr id="7" name="Text 5"/>
+          <p:cNvSpPr txBox="1"/>
+          <p:nvPr/>
+        </p:nvSpPr>
+        <p:spPr>
+          <a:xfrm>
+            <a:off x="1325880" y="2578608"/>
             <a:ext cx="4480560" cy="365760"/>
           </a:xfrm>
           <a:prstGeom prst="rect">
@@ -9672,7 +10408,535 @@
                 <a:ea typeface="Calibri" pitchFamily="34" charset="-122"/>
                 <a:cs typeface="Calibri" pitchFamily="34" charset="-120"/>
               </a:rPr>
-              <a:t>README + architecture doc + 21 passing tests</a:t>
+              <a:t>-39% weather RMSE · +22 pts AD (AUC 0.79)</a:t>
+            </a:r>
+            <a:endParaRPr lang="en-US" sz="1250" dirty="0"/>
+          </a:p>
+        </p:txBody>
+      </p:sp>
+      <p:sp>
+        <p:nvSpPr>
+          <p:cNvPr id="8" name="Shape 6"/>
+          <p:cNvSpPr/>
+          <p:nvPr/>
+        </p:nvSpPr>
+        <p:spPr>
+          <a:xfrm>
+            <a:off x="6172200" y="2103120"/>
+            <a:ext cx="5074920" cy="914400"/>
+          </a:xfrm>
+          <a:prstGeom prst="roundRect">
+            <a:avLst>
+              <a:gd name="adj" fmla="val 9000"/>
+            </a:avLst>
+          </a:prstGeom>
+          <a:solidFill>
+            <a:srgbClr val="16223A"/>
+          </a:solidFill>
+          <a:ln w="12700">
+            <a:solidFill>
+              <a:srgbClr val="2A3A5C"/>
+            </a:solidFill>
+            <a:prstDash val="solid"/>
+          </a:ln>
+          <a:effectLst>
+            <a:outerShdw sx="100000" sy="100000" kx="0" ky="0" algn="bl" rotWithShape="0" blurRad="101600" dist="38100" dir="5400000">
+              <a:srgbClr val="000000">
+                <a:alpha val="35000"/>
+              </a:srgbClr>
+            </a:outerShdw>
+          </a:effectLst>
+        </p:spPr>
+      </p:sp>
+      <p:sp>
+        <p:nvSpPr>
+          <p:cNvPr id="9" name="Shape 7"/>
+          <p:cNvSpPr/>
+          <p:nvPr/>
+        </p:nvSpPr>
+        <p:spPr>
+          <a:xfrm>
+            <a:off x="6428232" y="2487168"/>
+            <a:ext cx="146304" cy="146304"/>
+          </a:xfrm>
+          <a:prstGeom prst="ellipse">
+            <a:avLst/>
+          </a:prstGeom>
+          <a:solidFill>
+            <a:srgbClr val="4DA3FF"/>
+          </a:solidFill>
+          <a:ln/>
+        </p:spPr>
+      </p:sp>
+      <p:sp>
+        <p:nvSpPr>
+          <p:cNvPr id="10" name="Text 8"/>
+          <p:cNvSpPr txBox="1"/>
+          <p:nvPr/>
+        </p:nvSpPr>
+        <p:spPr>
+          <a:xfrm>
+            <a:off x="6675120" y="2221992"/>
+            <a:ext cx="4480560" cy="365760"/>
+          </a:xfrm>
+          <a:prstGeom prst="rect">
+            <a:avLst/>
+          </a:prstGeom>
+          <a:noFill/>
+          <a:ln/>
+        </p:spPr>
+        <p:txBody>
+          <a:bodyPr wrap="square" lIns="0" tIns="0" rIns="0" bIns="0" rtlCol="0" anchor="ctr"/>
+          <a:lstStyle/>
+          <a:p>
+            <a:pPr indent="0" marL="0">
+              <a:buNone/>
+            </a:pPr>
+            <a:r>
+              <a:rPr lang="en-US" sz="1500" b="1" dirty="0">
+                <a:solidFill>
+                  <a:srgbClr val="E8EEF7"/>
+                </a:solidFill>
+                <a:latin typeface="Arial" pitchFamily="34" charset="0"/>
+                <a:ea typeface="Arial" pitchFamily="34" charset="-122"/>
+                <a:cs typeface="Arial" pitchFamily="34" charset="-120"/>
+              </a:rPr>
+              <a:t>Route efficiency</a:t>
+            </a:r>
+            <a:endParaRPr lang="en-US" sz="1500" dirty="0"/>
+          </a:p>
+        </p:txBody>
+      </p:sp>
+      <p:sp>
+        <p:nvSpPr>
+          <p:cNvPr id="11" name="Text 9"/>
+          <p:cNvSpPr txBox="1"/>
+          <p:nvPr/>
+        </p:nvSpPr>
+        <p:spPr>
+          <a:xfrm>
+            <a:off x="6675120" y="2578608"/>
+            <a:ext cx="4480560" cy="365760"/>
+          </a:xfrm>
+          <a:prstGeom prst="rect">
+            <a:avLst/>
+          </a:prstGeom>
+          <a:noFill/>
+          <a:ln/>
+        </p:spPr>
+        <p:txBody>
+          <a:bodyPr wrap="square" lIns="0" tIns="0" rIns="0" bIns="0" rtlCol="0" anchor="ctr"/>
+          <a:lstStyle/>
+          <a:p>
+            <a:pPr indent="0" marL="0">
+              <a:buNone/>
+            </a:pPr>
+            <a:r>
+              <a:rPr lang="en-US" sz="1250" dirty="0">
+                <a:solidFill>
+                  <a:srgbClr val="90A4C4"/>
+                </a:solidFill>
+                <a:latin typeface="Calibri" pitchFamily="34" charset="0"/>
+                <a:ea typeface="Calibri" pitchFamily="34" charset="-122"/>
+                <a:cs typeface="Calibri" pitchFamily="34" charset="-120"/>
+              </a:rPr>
+              <a:t>time / fuel / risk per route; detours keep risk ~7%</a:t>
+            </a:r>
+            <a:endParaRPr lang="en-US" sz="1250" dirty="0"/>
+          </a:p>
+        </p:txBody>
+      </p:sp>
+      <p:sp>
+        <p:nvSpPr>
+          <p:cNvPr id="12" name="Shape 10"/>
+          <p:cNvSpPr/>
+          <p:nvPr/>
+        </p:nvSpPr>
+        <p:spPr>
+          <a:xfrm>
+            <a:off x="822960" y="3154680"/>
+            <a:ext cx="5074920" cy="914400"/>
+          </a:xfrm>
+          <a:prstGeom prst="roundRect">
+            <a:avLst>
+              <a:gd name="adj" fmla="val 9000"/>
+            </a:avLst>
+          </a:prstGeom>
+          <a:solidFill>
+            <a:srgbClr val="16223A"/>
+          </a:solidFill>
+          <a:ln w="12700">
+            <a:solidFill>
+              <a:srgbClr val="2A3A5C"/>
+            </a:solidFill>
+            <a:prstDash val="solid"/>
+          </a:ln>
+          <a:effectLst>
+            <a:outerShdw sx="100000" sy="100000" kx="0" ky="0" algn="bl" rotWithShape="0" blurRad="101600" dist="38100" dir="5400000">
+              <a:srgbClr val="000000">
+                <a:alpha val="35000"/>
+              </a:srgbClr>
+            </a:outerShdw>
+          </a:effectLst>
+        </p:spPr>
+      </p:sp>
+      <p:sp>
+        <p:nvSpPr>
+          <p:cNvPr id="13" name="Shape 11"/>
+          <p:cNvSpPr/>
+          <p:nvPr/>
+        </p:nvSpPr>
+        <p:spPr>
+          <a:xfrm>
+            <a:off x="1078992" y="3538728"/>
+            <a:ext cx="146304" cy="146304"/>
+          </a:xfrm>
+          <a:prstGeom prst="ellipse">
+            <a:avLst/>
+          </a:prstGeom>
+          <a:solidFill>
+            <a:srgbClr val="F5B942"/>
+          </a:solidFill>
+          <a:ln/>
+        </p:spPr>
+      </p:sp>
+      <p:sp>
+        <p:nvSpPr>
+          <p:cNvPr id="14" name="Text 12"/>
+          <p:cNvSpPr txBox="1"/>
+          <p:nvPr/>
+        </p:nvSpPr>
+        <p:spPr>
+          <a:xfrm>
+            <a:off x="1325880" y="3273552"/>
+            <a:ext cx="4480560" cy="365760"/>
+          </a:xfrm>
+          <a:prstGeom prst="rect">
+            <a:avLst/>
+          </a:prstGeom>
+          <a:noFill/>
+          <a:ln/>
+        </p:spPr>
+        <p:txBody>
+          <a:bodyPr wrap="square" lIns="0" tIns="0" rIns="0" bIns="0" rtlCol="0" anchor="ctr"/>
+          <a:lstStyle/>
+          <a:p>
+            <a:pPr indent="0" marL="0">
+              <a:buNone/>
+            </a:pPr>
+            <a:r>
+              <a:rPr lang="en-US" sz="1500" b="1" dirty="0">
+                <a:solidFill>
+                  <a:srgbClr val="E8EEF7"/>
+                </a:solidFill>
+                <a:latin typeface="Arial" pitchFamily="34" charset="0"/>
+                <a:ea typeface="Arial" pitchFamily="34" charset="-122"/>
+                <a:cs typeface="Arial" pitchFamily="34" charset="-120"/>
+              </a:rPr>
+              <a:t>Innovation</a:t>
+            </a:r>
+            <a:endParaRPr lang="en-US" sz="1500" dirty="0"/>
+          </a:p>
+        </p:txBody>
+      </p:sp>
+      <p:sp>
+        <p:nvSpPr>
+          <p:cNvPr id="15" name="Text 13"/>
+          <p:cNvSpPr txBox="1"/>
+          <p:nvPr/>
+        </p:nvSpPr>
+        <p:spPr>
+          <a:xfrm>
+            <a:off x="1325880" y="3630168"/>
+            <a:ext cx="4480560" cy="365760"/>
+          </a:xfrm>
+          <a:prstGeom prst="rect">
+            <a:avLst/>
+          </a:prstGeom>
+          <a:noFill/>
+          <a:ln/>
+        </p:spPr>
+        <p:txBody>
+          <a:bodyPr wrap="square" lIns="0" tIns="0" rIns="0" bIns="0" rtlCol="0" anchor="ctr"/>
+          <a:lstStyle/>
+          <a:p>
+            <a:pPr indent="0" marL="0">
+              <a:buNone/>
+            </a:pPr>
+            <a:r>
+              <a:rPr lang="en-US" sz="1250" dirty="0">
+                <a:solidFill>
+                  <a:srgbClr val="90A4C4"/>
+                </a:solidFill>
+                <a:latin typeface="Calibri" pitchFamily="34" charset="0"/>
+                <a:ea typeface="Calibri" pitchFamily="34" charset="-122"/>
+                <a:cs typeface="Calibri" pitchFamily="34" charset="-120"/>
+              </a:rPr>
+              <a:t>D* Lite + terrain-masking + 3D NOE + Pareto + robust</a:t>
+            </a:r>
+            <a:endParaRPr lang="en-US" sz="1250" dirty="0"/>
+          </a:p>
+        </p:txBody>
+      </p:sp>
+      <p:sp>
+        <p:nvSpPr>
+          <p:cNvPr id="16" name="Shape 14"/>
+          <p:cNvSpPr/>
+          <p:nvPr/>
+        </p:nvSpPr>
+        <p:spPr>
+          <a:xfrm>
+            <a:off x="6172200" y="3154680"/>
+            <a:ext cx="5074920" cy="914400"/>
+          </a:xfrm>
+          <a:prstGeom prst="roundRect">
+            <a:avLst>
+              <a:gd name="adj" fmla="val 9000"/>
+            </a:avLst>
+          </a:prstGeom>
+          <a:solidFill>
+            <a:srgbClr val="16223A"/>
+          </a:solidFill>
+          <a:ln w="12700">
+            <a:solidFill>
+              <a:srgbClr val="2A3A5C"/>
+            </a:solidFill>
+            <a:prstDash val="solid"/>
+          </a:ln>
+          <a:effectLst>
+            <a:outerShdw sx="100000" sy="100000" kx="0" ky="0" algn="bl" rotWithShape="0" blurRad="101600" dist="38100" dir="5400000">
+              <a:srgbClr val="000000">
+                <a:alpha val="35000"/>
+              </a:srgbClr>
+            </a:outerShdw>
+          </a:effectLst>
+        </p:spPr>
+      </p:sp>
+      <p:sp>
+        <p:nvSpPr>
+          <p:cNvPr id="17" name="Shape 15"/>
+          <p:cNvSpPr/>
+          <p:nvPr/>
+        </p:nvSpPr>
+        <p:spPr>
+          <a:xfrm>
+            <a:off x="6428232" y="3538728"/>
+            <a:ext cx="146304" cy="146304"/>
+          </a:xfrm>
+          <a:prstGeom prst="ellipse">
+            <a:avLst/>
+          </a:prstGeom>
+          <a:solidFill>
+            <a:srgbClr val="4DA3FF"/>
+          </a:solidFill>
+          <a:ln/>
+        </p:spPr>
+      </p:sp>
+      <p:sp>
+        <p:nvSpPr>
+          <p:cNvPr id="18" name="Text 16"/>
+          <p:cNvSpPr txBox="1"/>
+          <p:nvPr/>
+        </p:nvSpPr>
+        <p:spPr>
+          <a:xfrm>
+            <a:off x="6675120" y="3273552"/>
+            <a:ext cx="4480560" cy="365760"/>
+          </a:xfrm>
+          <a:prstGeom prst="rect">
+            <a:avLst/>
+          </a:prstGeom>
+          <a:noFill/>
+          <a:ln/>
+        </p:spPr>
+        <p:txBody>
+          <a:bodyPr wrap="square" lIns="0" tIns="0" rIns="0" bIns="0" rtlCol="0" anchor="ctr"/>
+          <a:lstStyle/>
+          <a:p>
+            <a:pPr indent="0" marL="0">
+              <a:buNone/>
+            </a:pPr>
+            <a:r>
+              <a:rPr lang="en-US" sz="1500" b="1" dirty="0">
+                <a:solidFill>
+                  <a:srgbClr val="E8EEF7"/>
+                </a:solidFill>
+                <a:latin typeface="Arial" pitchFamily="34" charset="0"/>
+                <a:ea typeface="Arial" pitchFamily="34" charset="-122"/>
+                <a:cs typeface="Arial" pitchFamily="34" charset="-120"/>
+              </a:rPr>
+              <a:t>User interface</a:t>
+            </a:r>
+            <a:endParaRPr lang="en-US" sz="1500" dirty="0"/>
+          </a:p>
+        </p:txBody>
+      </p:sp>
+      <p:sp>
+        <p:nvSpPr>
+          <p:cNvPr id="19" name="Text 17"/>
+          <p:cNvSpPr txBox="1"/>
+          <p:nvPr/>
+        </p:nvSpPr>
+        <p:spPr>
+          <a:xfrm>
+            <a:off x="6675120" y="3630168"/>
+            <a:ext cx="4480560" cy="365760"/>
+          </a:xfrm>
+          <a:prstGeom prst="rect">
+            <a:avLst/>
+          </a:prstGeom>
+          <a:noFill/>
+          <a:ln/>
+        </p:spPr>
+        <p:txBody>
+          <a:bodyPr wrap="square" lIns="0" tIns="0" rIns="0" bIns="0" rtlCol="0" anchor="ctr"/>
+          <a:lstStyle/>
+          <a:p>
+            <a:pPr indent="0" marL="0">
+              <a:buNone/>
+            </a:pPr>
+            <a:r>
+              <a:rPr lang="en-US" sz="1250" dirty="0">
+                <a:solidFill>
+                  <a:srgbClr val="90A4C4"/>
+                </a:solidFill>
+                <a:latin typeface="Calibri" pitchFamily="34" charset="0"/>
+                <a:ea typeface="Calibri" pitchFamily="34" charset="-122"/>
+                <a:cs typeface="Calibri" pitchFamily="34" charset="-120"/>
+              </a:rPr>
+              <a:t>live dashboard + click-to-place mission builder</a:t>
+            </a:r>
+            <a:endParaRPr lang="en-US" sz="1250" dirty="0"/>
+          </a:p>
+        </p:txBody>
+      </p:sp>
+      <p:sp>
+        <p:nvSpPr>
+          <p:cNvPr id="20" name="Shape 18"/>
+          <p:cNvSpPr/>
+          <p:nvPr/>
+        </p:nvSpPr>
+        <p:spPr>
+          <a:xfrm>
+            <a:off x="822960" y="4206240"/>
+            <a:ext cx="5074920" cy="914400"/>
+          </a:xfrm>
+          <a:prstGeom prst="roundRect">
+            <a:avLst>
+              <a:gd name="adj" fmla="val 9000"/>
+            </a:avLst>
+          </a:prstGeom>
+          <a:solidFill>
+            <a:srgbClr val="16223A"/>
+          </a:solidFill>
+          <a:ln w="12700">
+            <a:solidFill>
+              <a:srgbClr val="2A3A5C"/>
+            </a:solidFill>
+            <a:prstDash val="solid"/>
+          </a:ln>
+          <a:effectLst>
+            <a:outerShdw sx="100000" sy="100000" kx="0" ky="0" algn="bl" rotWithShape="0" blurRad="101600" dist="38100" dir="5400000">
+              <a:srgbClr val="000000">
+                <a:alpha val="35000"/>
+              </a:srgbClr>
+            </a:outerShdw>
+          </a:effectLst>
+        </p:spPr>
+      </p:sp>
+      <p:sp>
+        <p:nvSpPr>
+          <p:cNvPr id="21" name="Shape 19"/>
+          <p:cNvSpPr/>
+          <p:nvPr/>
+        </p:nvSpPr>
+        <p:spPr>
+          <a:xfrm>
+            <a:off x="1078992" y="4590288"/>
+            <a:ext cx="146304" cy="146304"/>
+          </a:xfrm>
+          <a:prstGeom prst="ellipse">
+            <a:avLst/>
+          </a:prstGeom>
+          <a:solidFill>
+            <a:srgbClr val="33D171"/>
+          </a:solidFill>
+          <a:ln/>
+        </p:spPr>
+      </p:sp>
+      <p:sp>
+        <p:nvSpPr>
+          <p:cNvPr id="22" name="Text 20"/>
+          <p:cNvSpPr txBox="1"/>
+          <p:nvPr/>
+        </p:nvSpPr>
+        <p:spPr>
+          <a:xfrm>
+            <a:off x="1325880" y="4325112"/>
+            <a:ext cx="4480560" cy="365760"/>
+          </a:xfrm>
+          <a:prstGeom prst="rect">
+            <a:avLst/>
+          </a:prstGeom>
+          <a:noFill/>
+          <a:ln/>
+        </p:spPr>
+        <p:txBody>
+          <a:bodyPr wrap="square" lIns="0" tIns="0" rIns="0" bIns="0" rtlCol="0" anchor="ctr"/>
+          <a:lstStyle/>
+          <a:p>
+            <a:pPr indent="0" marL="0">
+              <a:buNone/>
+            </a:pPr>
+            <a:r>
+              <a:rPr lang="en-US" sz="1500" b="1" dirty="0">
+                <a:solidFill>
+                  <a:srgbClr val="E8EEF7"/>
+                </a:solidFill>
+                <a:latin typeface="Arial" pitchFamily="34" charset="0"/>
+                <a:ea typeface="Arial" pitchFamily="34" charset="-122"/>
+                <a:cs typeface="Arial" pitchFamily="34" charset="-120"/>
+              </a:rPr>
+              <a:t>Documentation</a:t>
+            </a:r>
+            <a:endParaRPr lang="en-US" sz="1500" dirty="0"/>
+          </a:p>
+        </p:txBody>
+      </p:sp>
+      <p:sp>
+        <p:nvSpPr>
+          <p:cNvPr id="23" name="Text 21"/>
+          <p:cNvSpPr txBox="1"/>
+          <p:nvPr/>
+        </p:nvSpPr>
+        <p:spPr>
+          <a:xfrm>
+            <a:off x="1325880" y="4681728"/>
+            <a:ext cx="4480560" cy="365760"/>
+          </a:xfrm>
+          <a:prstGeom prst="rect">
+            <a:avLst/>
+          </a:prstGeom>
+          <a:noFill/>
+          <a:ln/>
+        </p:spPr>
+        <p:txBody>
+          <a:bodyPr wrap="square" lIns="0" tIns="0" rIns="0" bIns="0" rtlCol="0" anchor="ctr"/>
+          <a:lstStyle/>
+          <a:p>
+            <a:pPr indent="0" marL="0">
+              <a:buNone/>
+            </a:pPr>
+            <a:r>
+              <a:rPr lang="en-US" sz="1250" dirty="0">
+                <a:solidFill>
+                  <a:srgbClr val="90A4C4"/>
+                </a:solidFill>
+                <a:latin typeface="Calibri" pitchFamily="34" charset="0"/>
+                <a:ea typeface="Calibri" pitchFamily="34" charset="-122"/>
+                <a:cs typeface="Calibri" pitchFamily="34" charset="-120"/>
+              </a:rPr>
+              <a:t>README + architecture doc + 27 passing tests</a:t>
             </a:r>
             <a:endParaRPr lang="en-US" sz="1250" dirty="0"/>
           </a:p>

</xml_diff>